<commit_message>
State the raise as $700,000 and limit slide 9 to completed work
- Drops the "~$750,000 of sponsor and investor capital" framing from the
  phase plan and the execution slide. The raise is $700,000, offered as
  seven $100,000 secured notes, and the deck now says only that.
- Rebuilds slide 9 around delivered projects instead of the active
  pipeline, so the deck does not put concurrent development commitments in
  front of investors. The table now lists the six completed projects
  totaling 80 units.
- Adopts the headline figures from the July 2026 firm profile — $100M+ of
  completed for-sale construction, 140+ units built, owned and sold, and a
  50+ unit rental portfolio — which the profile documents directly.

Co-Authored-By: Claude Opus 5 <noreply@anthropic.com>
Claude-Session: https://claude.ai/code/session_01CYAVPhQRHuvkVD16PJtbYL
</commit_message>
<xml_diff>
--- a/deck/3331-Trumbull-Investor-Deck-Aug-2026.pptx
+++ b/deck/3331-Trumbull-Investor-Deck-Aug-2026.pptx
@@ -3828,7 +3828,7 @@
                 <a:ea typeface="Calibri" pitchFamily="34" charset="-122"/>
                 <a:cs typeface="Calibri" pitchFamily="34" charset="-120"/>
               </a:rPr>
-              <a:t>Why the raise is capped: Phase 1 needs roughly $750,000 of capital behind the First Merchants construction loan. $700,000 of that is offered as seven $100,000 secured notes to a small group of accredited investors. Phase 2 requires no additional raise.</a:t>
+              <a:t>Why the raise is capped: the raise is $700,000 — seven $100,000 secured notes to a small group of accredited investors — closing alongside the First Merchants construction loan to fund Phase 1. Phase 2 requires no additional raise.</a:t>
             </a:r>
             <a:endParaRPr lang="en-US" sz="1050" dirty="0"/>
           </a:p>
@@ -5966,7 +5966,7 @@
                 <a:ea typeface="Calibri" pitchFamily="34" charset="-122"/>
                 <a:cs typeface="Calibri" pitchFamily="34" charset="-120"/>
               </a:rPr>
-              <a:t>Funded by a First Merchants construction loan plus ~$750,000 of sponsor and investor capital</a:t>
+              <a:t>Funded by a First Merchants construction loan alongside the $700,000 investor note tranche</a:t>
             </a:r>
             <a:endParaRPr lang="en-US" sz="1050" dirty="0"/>
           </a:p>
@@ -5990,7 +5990,7 @@
                 <a:ea typeface="Calibri" pitchFamily="34" charset="-122"/>
                 <a:cs typeface="Calibri" pitchFamily="34" charset="-120"/>
               </a:rPr>
-              <a:t>$700,000 of that is the investor note tranche — seven $100,000 secured notes</a:t>
+              <a:t>Seven $100,000 secured notes — the full raise, and the only raise</a:t>
             </a:r>
             <a:endParaRPr lang="en-US" sz="1050" dirty="0"/>
           </a:p>
@@ -15510,7 +15510,7 @@
                 <a:ea typeface="Calibri" pitchFamily="34" charset="-122"/>
                 <a:cs typeface="Calibri" pitchFamily="34" charset="-120"/>
               </a:rPr>
-              <a:t>Vertically integrated developer and licensed general contractor across Southeast Michigan. Builder and owner on the portfolio below, with roughly 50 rental units held and ~$30M of development active today.
+              <a:t>Vertically integrated developer and licensed general contractor across Southeast Michigan. Builder and owner on 140+ residential for-sale units with more than $100M of completed construction, plus a ~50-unit rental portfolio he owns and his team operates.
 </a:t>
             </a:r>
             <a:pPr indent="0" marL="0">
@@ -15560,8 +15560,8 @@
         </p:nvSpPr>
         <p:spPr>
           <a:xfrm>
-            <a:off x="566928" y="4059936"/>
-            <a:ext cx="2542032" cy="1024128"/>
+            <a:off x="566928" y="4133088"/>
+            <a:ext cx="1664208" cy="1051560"/>
           </a:xfrm>
           <a:prstGeom prst="rect">
             <a:avLst/>
@@ -15592,7 +15592,7 @@
         </p:nvSpPr>
         <p:spPr>
           <a:xfrm>
-            <a:off x="768096" y="4242816"/>
+            <a:off x="768096" y="4315968"/>
             <a:ext cx="82296" cy="82296"/>
           </a:xfrm>
           <a:prstGeom prst="rect">
@@ -15612,24 +15612,24 @@
         </p:nvSpPr>
         <p:spPr>
           <a:xfrm>
-            <a:off x="768096" y="4352544"/>
-            <a:ext cx="2176272" cy="384048"/>
-          </a:xfrm>
-          <a:prstGeom prst="rect">
-            <a:avLst/>
-          </a:prstGeom>
-          <a:noFill/>
-          <a:ln/>
-        </p:spPr>
-        <p:txBody>
-          <a:bodyPr wrap="square" lIns="0" tIns="0" rIns="0" bIns="0" rtlCol="0" anchor="ctr"/>
-          <a:lstStyle/>
-          <a:p>
-            <a:pPr indent="0" marL="0">
-              <a:buNone/>
-            </a:pPr>
-            <a:r>
-              <a:rPr lang="en-US" sz="2500" b="1" dirty="0">
+            <a:off x="768096" y="4425696"/>
+            <a:ext cx="1298448" cy="384048"/>
+          </a:xfrm>
+          <a:prstGeom prst="rect">
+            <a:avLst/>
+          </a:prstGeom>
+          <a:noFill/>
+          <a:ln/>
+        </p:spPr>
+        <p:txBody>
+          <a:bodyPr wrap="square" lIns="0" tIns="0" rIns="0" bIns="0" rtlCol="0" anchor="ctr"/>
+          <a:lstStyle/>
+          <a:p>
+            <a:pPr indent="0" marL="0">
+              <a:buNone/>
+            </a:pPr>
+            <a:r>
+              <a:rPr lang="en-US" sz="2100" b="1" dirty="0">
                 <a:solidFill>
                   <a:srgbClr val="12303C"/>
                 </a:solidFill>
@@ -15637,9 +15637,9 @@
                 <a:ea typeface="Cambria" pitchFamily="34" charset="-122"/>
                 <a:cs typeface="Cambria" pitchFamily="34" charset="-120"/>
               </a:rPr>
-              <a:t>26</a:t>
-            </a:r>
-            <a:endParaRPr lang="en-US" sz="2500" dirty="0"/>
+              <a:t>$100M+</a:t>
+            </a:r>
+            <a:endParaRPr lang="en-US" sz="2100" dirty="0"/>
           </a:p>
         </p:txBody>
       </p:sp>
@@ -15651,8 +15651,8 @@
         </p:nvSpPr>
         <p:spPr>
           <a:xfrm>
-            <a:off x="768096" y="4736592"/>
-            <a:ext cx="2176272" cy="256032"/>
+            <a:off x="768096" y="4809744"/>
+            <a:ext cx="1298448" cy="283464"/>
           </a:xfrm>
           <a:prstGeom prst="rect">
             <a:avLst/>
@@ -15679,7 +15679,7 @@
                 <a:ea typeface="Calibri" pitchFamily="34" charset="-122"/>
                 <a:cs typeface="Calibri" pitchFamily="34" charset="-120"/>
               </a:rPr>
-              <a:t>TOTAL PROJECTS</a:t>
+              <a:t>COMPLETED</a:t>
             </a:r>
             <a:endParaRPr lang="en-US" sz="850" dirty="0"/>
           </a:p>
@@ -15699,7 +15699,7 @@
                 <a:ea typeface="Calibri" pitchFamily="34" charset="-122"/>
                 <a:cs typeface="Calibri" pitchFamily="34" charset="-120"/>
               </a:rPr>
-              <a:t>BUILT OR ACTIVE</a:t>
+              <a:t>CONSTRUCTION</a:t>
             </a:r>
             <a:endParaRPr lang="en-US" sz="850" dirty="0"/>
           </a:p>
@@ -15713,8 +15713,8 @@
         </p:nvSpPr>
         <p:spPr>
           <a:xfrm>
-            <a:off x="3218688" y="4059936"/>
-            <a:ext cx="2542032" cy="1024128"/>
+            <a:off x="2331720" y="4133088"/>
+            <a:ext cx="1664208" cy="1051560"/>
           </a:xfrm>
           <a:prstGeom prst="rect">
             <a:avLst/>
@@ -15745,7 +15745,7 @@
         </p:nvSpPr>
         <p:spPr>
           <a:xfrm>
-            <a:off x="3419856" y="4242816"/>
+            <a:off x="2532888" y="4315968"/>
             <a:ext cx="82296" cy="82296"/>
           </a:xfrm>
           <a:prstGeom prst="rect">
@@ -15765,24 +15765,24 @@
         </p:nvSpPr>
         <p:spPr>
           <a:xfrm>
-            <a:off x="3419856" y="4352544"/>
-            <a:ext cx="2176272" cy="384048"/>
-          </a:xfrm>
-          <a:prstGeom prst="rect">
-            <a:avLst/>
-          </a:prstGeom>
-          <a:noFill/>
-          <a:ln/>
-        </p:spPr>
-        <p:txBody>
-          <a:bodyPr wrap="square" lIns="0" tIns="0" rIns="0" bIns="0" rtlCol="0" anchor="ctr"/>
-          <a:lstStyle/>
-          <a:p>
-            <a:pPr indent="0" marL="0">
-              <a:buNone/>
-            </a:pPr>
-            <a:r>
-              <a:rPr lang="en-US" sz="2500" b="1" dirty="0">
+            <a:off x="2532888" y="4425696"/>
+            <a:ext cx="1298448" cy="384048"/>
+          </a:xfrm>
+          <a:prstGeom prst="rect">
+            <a:avLst/>
+          </a:prstGeom>
+          <a:noFill/>
+          <a:ln/>
+        </p:spPr>
+        <p:txBody>
+          <a:bodyPr wrap="square" lIns="0" tIns="0" rIns="0" bIns="0" rtlCol="0" anchor="ctr"/>
+          <a:lstStyle/>
+          <a:p>
+            <a:pPr indent="0" marL="0">
+              <a:buNone/>
+            </a:pPr>
+            <a:r>
+              <a:rPr lang="en-US" sz="2100" b="1" dirty="0">
                 <a:solidFill>
                   <a:srgbClr val="12303C"/>
                 </a:solidFill>
@@ -15790,9 +15790,9 @@
                 <a:ea typeface="Cambria" pitchFamily="34" charset="-122"/>
                 <a:cs typeface="Cambria" pitchFamily="34" charset="-120"/>
               </a:rPr>
-              <a:t>122</a:t>
-            </a:r>
-            <a:endParaRPr lang="en-US" sz="2500" dirty="0"/>
+              <a:t>140+</a:t>
+            </a:r>
+            <a:endParaRPr lang="en-US" sz="2100" dirty="0"/>
           </a:p>
         </p:txBody>
       </p:sp>
@@ -15804,8 +15804,8 @@
         </p:nvSpPr>
         <p:spPr>
           <a:xfrm>
-            <a:off x="3419856" y="4736592"/>
-            <a:ext cx="2176272" cy="256032"/>
+            <a:off x="2532888" y="4809744"/>
+            <a:ext cx="1298448" cy="283464"/>
           </a:xfrm>
           <a:prstGeom prst="rect">
             <a:avLst/>
@@ -15832,7 +15832,7 @@
                 <a:ea typeface="Calibri" pitchFamily="34" charset="-122"/>
                 <a:cs typeface="Calibri" pitchFamily="34" charset="-120"/>
               </a:rPr>
-              <a:t>TOTAL UNITS</a:t>
+              <a:t>UNITS BUILT</a:t>
             </a:r>
             <a:endParaRPr lang="en-US" sz="850" dirty="0"/>
           </a:p>
@@ -15852,7 +15852,7 @@
                 <a:ea typeface="Calibri" pitchFamily="34" charset="-122"/>
                 <a:cs typeface="Calibri" pitchFamily="34" charset="-120"/>
               </a:rPr>
-              <a:t>ACROSS PORTFOLIO</a:t>
+              <a:t>&amp; SOLD</a:t>
             </a:r>
             <a:endParaRPr lang="en-US" sz="850" dirty="0"/>
           </a:p>
@@ -15866,8 +15866,8 @@
         </p:nvSpPr>
         <p:spPr>
           <a:xfrm>
-            <a:off x="566928" y="5157216"/>
-            <a:ext cx="2542032" cy="1024128"/>
+            <a:off x="4096512" y="4133088"/>
+            <a:ext cx="1664208" cy="1051560"/>
           </a:xfrm>
           <a:prstGeom prst="rect">
             <a:avLst/>
@@ -15898,7 +15898,7 @@
         </p:nvSpPr>
         <p:spPr>
           <a:xfrm>
-            <a:off x="768096" y="5340096"/>
+            <a:off x="4297680" y="4315968"/>
             <a:ext cx="82296" cy="82296"/>
           </a:xfrm>
           <a:prstGeom prst="rect">
@@ -15918,24 +15918,24 @@
         </p:nvSpPr>
         <p:spPr>
           <a:xfrm>
-            <a:off x="768096" y="5449824"/>
-            <a:ext cx="2176272" cy="384048"/>
-          </a:xfrm>
-          <a:prstGeom prst="rect">
-            <a:avLst/>
-          </a:prstGeom>
-          <a:noFill/>
-          <a:ln/>
-        </p:spPr>
-        <p:txBody>
-          <a:bodyPr wrap="square" lIns="0" tIns="0" rIns="0" bIns="0" rtlCol="0" anchor="ctr"/>
-          <a:lstStyle/>
-          <a:p>
-            <a:pPr indent="0" marL="0">
-              <a:buNone/>
-            </a:pPr>
-            <a:r>
-              <a:rPr lang="en-US" sz="2500" b="1" dirty="0">
+            <a:off x="4297680" y="4425696"/>
+            <a:ext cx="1298448" cy="384048"/>
+          </a:xfrm>
+          <a:prstGeom prst="rect">
+            <a:avLst/>
+          </a:prstGeom>
+          <a:noFill/>
+          <a:ln/>
+        </p:spPr>
+        <p:txBody>
+          <a:bodyPr wrap="square" lIns="0" tIns="0" rIns="0" bIns="0" rtlCol="0" anchor="ctr"/>
+          <a:lstStyle/>
+          <a:p>
+            <a:pPr indent="0" marL="0">
+              <a:buNone/>
+            </a:pPr>
+            <a:r>
+              <a:rPr lang="en-US" sz="2100" b="1" dirty="0">
                 <a:solidFill>
                   <a:srgbClr val="12303C"/>
                 </a:solidFill>
@@ -15943,9 +15943,9 @@
                 <a:ea typeface="Cambria" pitchFamily="34" charset="-122"/>
                 <a:cs typeface="Cambria" pitchFamily="34" charset="-120"/>
               </a:rPr>
-              <a:t>75</a:t>
-            </a:r>
-            <a:endParaRPr lang="en-US" sz="2500" dirty="0"/>
+              <a:t>50+</a:t>
+            </a:r>
+            <a:endParaRPr lang="en-US" sz="2100" dirty="0"/>
           </a:p>
         </p:txBody>
       </p:sp>
@@ -15957,8 +15957,8 @@
         </p:nvSpPr>
         <p:spPr>
           <a:xfrm>
-            <a:off x="768096" y="5833872"/>
-            <a:ext cx="2176272" cy="256032"/>
+            <a:off x="4297680" y="4809744"/>
+            <a:ext cx="1298448" cy="283464"/>
           </a:xfrm>
           <a:prstGeom prst="rect">
             <a:avLst/>
@@ -15985,7 +15985,7 @@
                 <a:ea typeface="Calibri" pitchFamily="34" charset="-122"/>
                 <a:cs typeface="Calibri" pitchFamily="34" charset="-120"/>
               </a:rPr>
-              <a:t>UNITS DELIVERED</a:t>
+              <a:t>RENTAL UNITS</a:t>
             </a:r>
             <a:endParaRPr lang="en-US" sz="850" dirty="0"/>
           </a:p>
@@ -16005,7 +16005,7 @@
                 <a:ea typeface="Calibri" pitchFamily="34" charset="-122"/>
                 <a:cs typeface="Calibri" pitchFamily="34" charset="-120"/>
               </a:rPr>
-              <a:t>20 COMPLETED PROJECTS</a:t>
+              <a:t>OWNED</a:t>
             </a:r>
             <a:endParaRPr lang="en-US" sz="850" dirty="0"/>
           </a:p>
@@ -16019,8 +16019,150 @@
         </p:nvSpPr>
         <p:spPr>
           <a:xfrm>
-            <a:off x="3218688" y="5157216"/>
-            <a:ext cx="2542032" cy="1024128"/>
+            <a:off x="5943600" y="1664208"/>
+            <a:ext cx="5650992" cy="292608"/>
+          </a:xfrm>
+          <a:prstGeom prst="rect">
+            <a:avLst/>
+          </a:prstGeom>
+          <a:solidFill>
+            <a:srgbClr val="F0F4F5"/>
+          </a:solidFill>
+          <a:ln w="9525">
+            <a:solidFill>
+              <a:srgbClr val="E2E8E9"/>
+            </a:solidFill>
+            <a:prstDash val="solid"/>
+          </a:ln>
+        </p:spPr>
+      </p:sp>
+      <p:sp>
+        <p:nvSpPr>
+          <p:cNvPr id="19" name="Text 17"/>
+          <p:cNvSpPr/>
+          <p:nvPr/>
+        </p:nvSpPr>
+        <p:spPr>
+          <a:xfrm>
+            <a:off x="6053328" y="1664208"/>
+            <a:ext cx="3024632" cy="292608"/>
+          </a:xfrm>
+          <a:prstGeom prst="rect">
+            <a:avLst/>
+          </a:prstGeom>
+          <a:noFill/>
+          <a:ln/>
+        </p:spPr>
+        <p:txBody>
+          <a:bodyPr wrap="square" lIns="0" tIns="0" rIns="0" bIns="0" rtlCol="0" anchor="ctr"/>
+          <a:lstStyle/>
+          <a:p>
+            <a:pPr algn="l" indent="0" marL="0">
+              <a:buNone/>
+            </a:pPr>
+            <a:r>
+              <a:rPr lang="en-US" sz="850" b="1" spc="120" kern="0" dirty="0">
+                <a:solidFill>
+                  <a:srgbClr val="6B8792"/>
+                </a:solidFill>
+                <a:latin typeface="Calibri" pitchFamily="34" charset="0"/>
+                <a:ea typeface="Calibri" pitchFamily="34" charset="-122"/>
+                <a:cs typeface="Calibri" pitchFamily="34" charset="-120"/>
+              </a:rPr>
+              <a:t>COMPLETED PROJECTS</a:t>
+            </a:r>
+            <a:endParaRPr lang="en-US" sz="850" dirty="0"/>
+          </a:p>
+        </p:txBody>
+      </p:sp>
+      <p:sp>
+        <p:nvSpPr>
+          <p:cNvPr id="20" name="Text 18"/>
+          <p:cNvSpPr/>
+          <p:nvPr/>
+        </p:nvSpPr>
+        <p:spPr>
+          <a:xfrm>
+            <a:off x="9297416" y="1664208"/>
+            <a:ext cx="1193292" cy="292608"/>
+          </a:xfrm>
+          <a:prstGeom prst="rect">
+            <a:avLst/>
+          </a:prstGeom>
+          <a:noFill/>
+          <a:ln/>
+        </p:spPr>
+        <p:txBody>
+          <a:bodyPr wrap="square" lIns="0" tIns="0" rIns="0" bIns="0" rtlCol="0" anchor="ctr"/>
+          <a:lstStyle/>
+          <a:p>
+            <a:pPr algn="r" indent="0" marL="0">
+              <a:buNone/>
+            </a:pPr>
+            <a:r>
+              <a:rPr lang="en-US" sz="850" b="1" spc="120" kern="0" dirty="0">
+                <a:solidFill>
+                  <a:srgbClr val="6B8792"/>
+                </a:solidFill>
+                <a:latin typeface="Calibri" pitchFamily="34" charset="0"/>
+                <a:ea typeface="Calibri" pitchFamily="34" charset="-122"/>
+                <a:cs typeface="Calibri" pitchFamily="34" charset="-120"/>
+              </a:rPr>
+              <a:t>TYPE</a:t>
+            </a:r>
+            <a:endParaRPr lang="en-US" sz="850" dirty="0"/>
+          </a:p>
+        </p:txBody>
+      </p:sp>
+      <p:sp>
+        <p:nvSpPr>
+          <p:cNvPr id="21" name="Text 19"/>
+          <p:cNvSpPr/>
+          <p:nvPr/>
+        </p:nvSpPr>
+        <p:spPr>
+          <a:xfrm>
+            <a:off x="10710164" y="1664208"/>
+            <a:ext cx="774700" cy="292608"/>
+          </a:xfrm>
+          <a:prstGeom prst="rect">
+            <a:avLst/>
+          </a:prstGeom>
+          <a:noFill/>
+          <a:ln/>
+        </p:spPr>
+        <p:txBody>
+          <a:bodyPr wrap="square" lIns="0" tIns="0" rIns="0" bIns="0" rtlCol="0" anchor="ctr"/>
+          <a:lstStyle/>
+          <a:p>
+            <a:pPr algn="r" indent="0" marL="0">
+              <a:buNone/>
+            </a:pPr>
+            <a:r>
+              <a:rPr lang="en-US" sz="850" b="1" spc="120" kern="0" dirty="0">
+                <a:solidFill>
+                  <a:srgbClr val="6B8792"/>
+                </a:solidFill>
+                <a:latin typeface="Calibri" pitchFamily="34" charset="0"/>
+                <a:ea typeface="Calibri" pitchFamily="34" charset="-122"/>
+                <a:cs typeface="Calibri" pitchFamily="34" charset="-120"/>
+              </a:rPr>
+              <a:t>UNITS</a:t>
+            </a:r>
+            <a:endParaRPr lang="en-US" sz="850" dirty="0"/>
+          </a:p>
+        </p:txBody>
+      </p:sp>
+      <p:sp>
+        <p:nvSpPr>
+          <p:cNvPr id="22" name="Shape 20"/>
+          <p:cNvSpPr/>
+          <p:nvPr/>
+        </p:nvSpPr>
+        <p:spPr>
+          <a:xfrm>
+            <a:off x="5943600" y="1956816"/>
+            <a:ext cx="5650992" cy="324612"/>
           </a:xfrm>
           <a:prstGeom prst="rect">
             <a:avLst/>
@@ -16034,197 +16176,44 @@
             </a:solidFill>
             <a:prstDash val="solid"/>
           </a:ln>
-          <a:effectLst>
-            <a:outerShdw sx="100000" sy="100000" kx="0" ky="0" algn="bl" rotWithShape="0" blurRad="101600" dist="25400" dir="5400000">
-              <a:srgbClr val="0B2029">
-                <a:alpha val="9000"/>
-              </a:srgbClr>
-            </a:outerShdw>
-          </a:effectLst>
-        </p:spPr>
-      </p:sp>
-      <p:sp>
-        <p:nvSpPr>
-          <p:cNvPr id="19" name="Shape 17"/>
-          <p:cNvSpPr/>
-          <p:nvPr/>
-        </p:nvSpPr>
-        <p:spPr>
-          <a:xfrm>
-            <a:off x="3419856" y="5340096"/>
-            <a:ext cx="82296" cy="82296"/>
-          </a:xfrm>
-          <a:prstGeom prst="rect">
-            <a:avLst/>
-          </a:prstGeom>
-          <a:solidFill>
-            <a:srgbClr val="D9A441"/>
-          </a:solidFill>
-          <a:ln/>
-        </p:spPr>
-      </p:sp>
-      <p:sp>
-        <p:nvSpPr>
-          <p:cNvPr id="20" name="Text 18"/>
-          <p:cNvSpPr/>
-          <p:nvPr/>
-        </p:nvSpPr>
-        <p:spPr>
-          <a:xfrm>
-            <a:off x="3419856" y="5449824"/>
-            <a:ext cx="2176272" cy="384048"/>
-          </a:xfrm>
-          <a:prstGeom prst="rect">
-            <a:avLst/>
-          </a:prstGeom>
-          <a:noFill/>
-          <a:ln/>
-        </p:spPr>
-        <p:txBody>
-          <a:bodyPr wrap="square" lIns="0" tIns="0" rIns="0" bIns="0" rtlCol="0" anchor="ctr"/>
-          <a:lstStyle/>
-          <a:p>
-            <a:pPr indent="0" marL="0">
-              <a:buNone/>
-            </a:pPr>
-            <a:r>
-              <a:rPr lang="en-US" sz="2500" b="1" dirty="0">
+        </p:spPr>
+      </p:sp>
+      <p:sp>
+        <p:nvSpPr>
+          <p:cNvPr id="23" name="Text 21"/>
+          <p:cNvSpPr/>
+          <p:nvPr/>
+        </p:nvSpPr>
+        <p:spPr>
+          <a:xfrm>
+            <a:off x="6053328" y="1956816"/>
+            <a:ext cx="3024632" cy="324612"/>
+          </a:xfrm>
+          <a:prstGeom prst="rect">
+            <a:avLst/>
+          </a:prstGeom>
+          <a:noFill/>
+          <a:ln/>
+        </p:spPr>
+        <p:txBody>
+          <a:bodyPr wrap="square" lIns="0" tIns="0" rIns="0" bIns="0" rtlCol="0" anchor="ctr"/>
+          <a:lstStyle/>
+          <a:p>
+            <a:pPr algn="l" indent="0" marL="0">
+              <a:buNone/>
+            </a:pPr>
+            <a:r>
+              <a:rPr lang="en-US" sz="1000" dirty="0">
                 <a:solidFill>
                   <a:srgbClr val="12303C"/>
                 </a:solidFill>
-                <a:latin typeface="Cambria" pitchFamily="34" charset="0"/>
-                <a:ea typeface="Cambria" pitchFamily="34" charset="-122"/>
-                <a:cs typeface="Cambria" pitchFamily="34" charset="-120"/>
-              </a:rPr>
-              <a:t>47</a:t>
-            </a:r>
-            <a:endParaRPr lang="en-US" sz="2500" dirty="0"/>
-          </a:p>
-        </p:txBody>
-      </p:sp>
-      <p:sp>
-        <p:nvSpPr>
-          <p:cNvPr id="21" name="Text 19"/>
-          <p:cNvSpPr/>
-          <p:nvPr/>
-        </p:nvSpPr>
-        <p:spPr>
-          <a:xfrm>
-            <a:off x="3419856" y="5833872"/>
-            <a:ext cx="2176272" cy="256032"/>
-          </a:xfrm>
-          <a:prstGeom prst="rect">
-            <a:avLst/>
-          </a:prstGeom>
-          <a:noFill/>
-          <a:ln/>
-        </p:spPr>
-        <p:txBody>
-          <a:bodyPr wrap="square" lIns="0" tIns="0" rIns="0" bIns="0" rtlCol="0" anchor="t"/>
-          <a:lstStyle/>
-          <a:p>
-            <a:pPr indent="0" marL="0">
-              <a:lnSpc>
-                <a:spcPts val="1050"/>
-              </a:lnSpc>
-              <a:buNone/>
-            </a:pPr>
-            <a:r>
-              <a:rPr lang="en-US" sz="850" spc="90" kern="0" dirty="0">
-                <a:solidFill>
-                  <a:srgbClr val="6B8792"/>
-                </a:solidFill>
-                <a:latin typeface="Calibri" pitchFamily="34" charset="0"/>
-                <a:ea typeface="Calibri" pitchFamily="34" charset="-122"/>
-                <a:cs typeface="Calibri" pitchFamily="34" charset="-120"/>
-              </a:rPr>
-              <a:t>UNITS IN DEVELOPMENT</a:t>
-            </a:r>
-            <a:endParaRPr lang="en-US" sz="850" dirty="0"/>
-          </a:p>
-          <a:p>
-            <a:pPr indent="0" marL="0">
-              <a:lnSpc>
-                <a:spcPts val="1050"/>
-              </a:lnSpc>
-              <a:buNone/>
-            </a:pPr>
-            <a:r>
-              <a:rPr lang="en-US" sz="850" spc="90" kern="0" dirty="0">
-                <a:solidFill>
-                  <a:srgbClr val="6B8792"/>
-                </a:solidFill>
-                <a:latin typeface="Calibri" pitchFamily="34" charset="0"/>
-                <a:ea typeface="Calibri" pitchFamily="34" charset="-122"/>
-                <a:cs typeface="Calibri" pitchFamily="34" charset="-120"/>
-              </a:rPr>
-              <a:t>6 ACTIVE PROJECTS</a:t>
-            </a:r>
-            <a:endParaRPr lang="en-US" sz="850" dirty="0"/>
-          </a:p>
-        </p:txBody>
-      </p:sp>
-      <p:sp>
-        <p:nvSpPr>
-          <p:cNvPr id="22" name="Shape 20"/>
-          <p:cNvSpPr/>
-          <p:nvPr/>
-        </p:nvSpPr>
-        <p:spPr>
-          <a:xfrm>
-            <a:off x="5943600" y="1664208"/>
-            <a:ext cx="5650992" cy="292608"/>
-          </a:xfrm>
-          <a:prstGeom prst="rect">
-            <a:avLst/>
-          </a:prstGeom>
-          <a:solidFill>
-            <a:srgbClr val="F0F4F5"/>
-          </a:solidFill>
-          <a:ln w="9525">
-            <a:solidFill>
-              <a:srgbClr val="E2E8E9"/>
-            </a:solidFill>
-            <a:prstDash val="solid"/>
-          </a:ln>
-        </p:spPr>
-      </p:sp>
-      <p:sp>
-        <p:nvSpPr>
-          <p:cNvPr id="23" name="Text 21"/>
-          <p:cNvSpPr/>
-          <p:nvPr/>
-        </p:nvSpPr>
-        <p:spPr>
-          <a:xfrm>
-            <a:off x="6053328" y="1664208"/>
-            <a:ext cx="2760158" cy="292608"/>
-          </a:xfrm>
-          <a:prstGeom prst="rect">
-            <a:avLst/>
-          </a:prstGeom>
-          <a:noFill/>
-          <a:ln/>
-        </p:spPr>
-        <p:txBody>
-          <a:bodyPr wrap="square" lIns="0" tIns="0" rIns="0" bIns="0" rtlCol="0" anchor="ctr"/>
-          <a:lstStyle/>
-          <a:p>
-            <a:pPr algn="l" indent="0" marL="0">
-              <a:buNone/>
-            </a:pPr>
-            <a:r>
-              <a:rPr lang="en-US" sz="850" b="1" spc="120" kern="0" dirty="0">
-                <a:solidFill>
-                  <a:srgbClr val="6B8792"/>
-                </a:solidFill>
-                <a:latin typeface="Calibri" pitchFamily="34" charset="0"/>
-                <a:ea typeface="Calibri" pitchFamily="34" charset="-122"/>
-                <a:cs typeface="Calibri" pitchFamily="34" charset="-120"/>
-              </a:rPr>
-              <a:t>ACTIVE PIPELINE</a:t>
-            </a:r>
-            <a:endParaRPr lang="en-US" sz="850" dirty="0"/>
+                <a:latin typeface="Calibri" pitchFamily="34" charset="0"/>
+                <a:ea typeface="Calibri" pitchFamily="34" charset="-122"/>
+                <a:cs typeface="Calibri" pitchFamily="34" charset="-120"/>
+              </a:rPr>
+              <a:t>Wesburn Villas</a:t>
+            </a:r>
+            <a:endParaRPr lang="en-US" sz="1000" dirty="0"/>
           </a:p>
         </p:txBody>
       </p:sp>
@@ -16236,8 +16225,8 @@
         </p:nvSpPr>
         <p:spPr>
           <a:xfrm>
-            <a:off x="9032942" y="1664208"/>
-            <a:ext cx="1321724" cy="292608"/>
+            <a:off x="9297416" y="1956816"/>
+            <a:ext cx="1193292" cy="324612"/>
           </a:xfrm>
           <a:prstGeom prst="rect">
             <a:avLst/>
@@ -16253,17 +16242,17 @@
               <a:buNone/>
             </a:pPr>
             <a:r>
-              <a:rPr lang="en-US" sz="850" b="1" spc="120" kern="0" dirty="0">
-                <a:solidFill>
-                  <a:srgbClr val="6B8792"/>
-                </a:solidFill>
-                <a:latin typeface="Calibri" pitchFamily="34" charset="0"/>
-                <a:ea typeface="Calibri" pitchFamily="34" charset="-122"/>
-                <a:cs typeface="Calibri" pitchFamily="34" charset="-120"/>
-              </a:rPr>
-              <a:t>TYPE</a:t>
-            </a:r>
-            <a:endParaRPr lang="en-US" sz="850" dirty="0"/>
+              <a:rPr lang="en-US" sz="1000" dirty="0">
+                <a:solidFill>
+                  <a:srgbClr val="47606B"/>
+                </a:solidFill>
+                <a:latin typeface="Calibri" pitchFamily="34" charset="0"/>
+                <a:ea typeface="Calibri" pitchFamily="34" charset="-122"/>
+                <a:cs typeface="Calibri" pitchFamily="34" charset="-120"/>
+              </a:rPr>
+              <a:t>Townhomes</a:t>
+            </a:r>
+            <a:endParaRPr lang="en-US" sz="1000" dirty="0"/>
           </a:p>
         </p:txBody>
       </p:sp>
@@ -16275,8 +16264,8 @@
         </p:nvSpPr>
         <p:spPr>
           <a:xfrm>
-            <a:off x="10574122" y="1664208"/>
-            <a:ext cx="910742" cy="292608"/>
+            <a:off x="10710164" y="1956816"/>
+            <a:ext cx="774700" cy="324612"/>
           </a:xfrm>
           <a:prstGeom prst="rect">
             <a:avLst/>
@@ -16292,17 +16281,17 @@
               <a:buNone/>
             </a:pPr>
             <a:r>
-              <a:rPr lang="en-US" sz="850" b="1" spc="120" kern="0" dirty="0">
-                <a:solidFill>
-                  <a:srgbClr val="6B8792"/>
-                </a:solidFill>
-                <a:latin typeface="Calibri" pitchFamily="34" charset="0"/>
-                <a:ea typeface="Calibri" pitchFamily="34" charset="-122"/>
-                <a:cs typeface="Calibri" pitchFamily="34" charset="-120"/>
-              </a:rPr>
-              <a:t>UNITS</a:t>
-            </a:r>
-            <a:endParaRPr lang="en-US" sz="850" dirty="0"/>
+              <a:rPr lang="en-US" sz="1000" dirty="0">
+                <a:solidFill>
+                  <a:srgbClr val="47606B"/>
+                </a:solidFill>
+                <a:latin typeface="Calibri" pitchFamily="34" charset="0"/>
+                <a:ea typeface="Calibri" pitchFamily="34" charset="-122"/>
+                <a:cs typeface="Calibri" pitchFamily="34" charset="-120"/>
+              </a:rPr>
+              <a:t>28</a:t>
+            </a:r>
+            <a:endParaRPr lang="en-US" sz="1000" dirty="0"/>
           </a:p>
         </p:txBody>
       </p:sp>
@@ -16314,7 +16303,7 @@
         </p:nvSpPr>
         <p:spPr>
           <a:xfrm>
-            <a:off x="5943600" y="1956816"/>
+            <a:off x="5943600" y="2281428"/>
             <a:ext cx="5650992" cy="324612"/>
           </a:xfrm>
           <a:prstGeom prst="rect">
@@ -16339,8 +16328,8 @@
         </p:nvSpPr>
         <p:spPr>
           <a:xfrm>
-            <a:off x="6053328" y="1956816"/>
-            <a:ext cx="2760158" cy="324612"/>
+            <a:off x="6053328" y="2281428"/>
+            <a:ext cx="3024632" cy="324612"/>
           </a:xfrm>
           <a:prstGeom prst="rect">
             <a:avLst/>
@@ -16364,7 +16353,7 @@
                 <a:ea typeface="Calibri" pitchFamily="34" charset="-122"/>
                 <a:cs typeface="Calibri" pitchFamily="34" charset="-120"/>
               </a:rPr>
-              <a:t>106 E. Forest — Detroit</a:t>
+              <a:t>iPG — Detroit</a:t>
             </a:r>
             <a:endParaRPr lang="en-US" sz="1000" dirty="0"/>
           </a:p>
@@ -16378,8 +16367,8 @@
         </p:nvSpPr>
         <p:spPr>
           <a:xfrm>
-            <a:off x="9032942" y="1956816"/>
-            <a:ext cx="1321724" cy="324612"/>
+            <a:off x="9297416" y="2281428"/>
+            <a:ext cx="1193292" cy="324612"/>
           </a:xfrm>
           <a:prstGeom prst="rect">
             <a:avLst/>
@@ -16417,8 +16406,8 @@
         </p:nvSpPr>
         <p:spPr>
           <a:xfrm>
-            <a:off x="10574122" y="1956816"/>
-            <a:ext cx="910742" cy="324612"/>
+            <a:off x="10710164" y="2281428"/>
+            <a:ext cx="774700" cy="324612"/>
           </a:xfrm>
           <a:prstGeom prst="rect">
             <a:avLst/>
@@ -16442,7 +16431,7 @@
                 <a:ea typeface="Calibri" pitchFamily="34" charset="-122"/>
                 <a:cs typeface="Calibri" pitchFamily="34" charset="-120"/>
               </a:rPr>
-              <a:t>12</a:t>
+              <a:t>16</a:t>
             </a:r>
             <a:endParaRPr lang="en-US" sz="1000" dirty="0"/>
           </a:p>
@@ -16456,7 +16445,7 @@
         </p:nvSpPr>
         <p:spPr>
           <a:xfrm>
-            <a:off x="5943600" y="2281428"/>
+            <a:off x="5943600" y="2606040"/>
             <a:ext cx="5650992" cy="324612"/>
           </a:xfrm>
           <a:prstGeom prst="rect">
@@ -16481,8 +16470,8 @@
         </p:nvSpPr>
         <p:spPr>
           <a:xfrm>
-            <a:off x="6053328" y="2281428"/>
-            <a:ext cx="2760158" cy="324612"/>
+            <a:off x="6053328" y="2606040"/>
+            <a:ext cx="3024632" cy="324612"/>
           </a:xfrm>
           <a:prstGeom prst="rect">
             <a:avLst/>
@@ -16506,7 +16495,7 @@
                 <a:ea typeface="Calibri" pitchFamily="34" charset="-122"/>
                 <a:cs typeface="Calibri" pitchFamily="34" charset="-120"/>
               </a:rPr>
-              <a:t>1530 Bagley — Detroit</a:t>
+              <a:t>Harrison 12 — North Corktown</a:t>
             </a:r>
             <a:endParaRPr lang="en-US" sz="1000" dirty="0"/>
           </a:p>
@@ -16520,8 +16509,8 @@
         </p:nvSpPr>
         <p:spPr>
           <a:xfrm>
-            <a:off x="9032942" y="2281428"/>
-            <a:ext cx="1321724" cy="324612"/>
+            <a:off x="9297416" y="2606040"/>
+            <a:ext cx="1193292" cy="324612"/>
           </a:xfrm>
           <a:prstGeom prst="rect">
             <a:avLst/>
@@ -16545,7 +16534,7 @@
                 <a:ea typeface="Calibri" pitchFamily="34" charset="-122"/>
                 <a:cs typeface="Calibri" pitchFamily="34" charset="-120"/>
               </a:rPr>
-              <a:t>Apartments</a:t>
+              <a:t>Townhomes</a:t>
             </a:r>
             <a:endParaRPr lang="en-US" sz="1000" dirty="0"/>
           </a:p>
@@ -16559,8 +16548,8 @@
         </p:nvSpPr>
         <p:spPr>
           <a:xfrm>
-            <a:off x="10574122" y="2281428"/>
-            <a:ext cx="910742" cy="324612"/>
+            <a:off x="10710164" y="2606040"/>
+            <a:ext cx="774700" cy="324612"/>
           </a:xfrm>
           <a:prstGeom prst="rect">
             <a:avLst/>
@@ -16598,7 +16587,7 @@
         </p:nvSpPr>
         <p:spPr>
           <a:xfrm>
-            <a:off x="5943600" y="2606040"/>
+            <a:off x="5943600" y="2930652"/>
             <a:ext cx="5650992" cy="324612"/>
           </a:xfrm>
           <a:prstGeom prst="rect">
@@ -16623,8 +16612,8 @@
         </p:nvSpPr>
         <p:spPr>
           <a:xfrm>
-            <a:off x="6053328" y="2606040"/>
-            <a:ext cx="2760158" cy="324612"/>
+            <a:off x="6053328" y="2930652"/>
+            <a:ext cx="3024632" cy="324612"/>
           </a:xfrm>
           <a:prstGeom prst="rect">
             <a:avLst/>
@@ -16648,7 +16637,7 @@
                 <a:ea typeface="Calibri" pitchFamily="34" charset="-122"/>
                 <a:cs typeface="Calibri" pitchFamily="34" charset="-120"/>
               </a:rPr>
-              <a:t>3984 Commonwealth — Detroit</a:t>
+              <a:t>North Corktown 11</a:t>
             </a:r>
             <a:endParaRPr lang="en-US" sz="1000" dirty="0"/>
           </a:p>
@@ -16662,8 +16651,8 @@
         </p:nvSpPr>
         <p:spPr>
           <a:xfrm>
-            <a:off x="9032942" y="2606040"/>
-            <a:ext cx="1321724" cy="324612"/>
+            <a:off x="9297416" y="2930652"/>
+            <a:ext cx="1193292" cy="324612"/>
           </a:xfrm>
           <a:prstGeom prst="rect">
             <a:avLst/>
@@ -16687,7 +16676,7 @@
                 <a:ea typeface="Calibri" pitchFamily="34" charset="-122"/>
                 <a:cs typeface="Calibri" pitchFamily="34" charset="-120"/>
               </a:rPr>
-              <a:t>Apartments</a:t>
+              <a:t>Townhomes</a:t>
             </a:r>
             <a:endParaRPr lang="en-US" sz="1000" dirty="0"/>
           </a:p>
@@ -16701,8 +16690,8 @@
         </p:nvSpPr>
         <p:spPr>
           <a:xfrm>
-            <a:off x="10574122" y="2606040"/>
-            <a:ext cx="910742" cy="324612"/>
+            <a:off x="10710164" y="2930652"/>
+            <a:ext cx="774700" cy="324612"/>
           </a:xfrm>
           <a:prstGeom prst="rect">
             <a:avLst/>
@@ -16726,7 +16715,7 @@
                 <a:ea typeface="Calibri" pitchFamily="34" charset="-122"/>
                 <a:cs typeface="Calibri" pitchFamily="34" charset="-120"/>
               </a:rPr>
-              <a:t>12</a:t>
+              <a:t>11</a:t>
             </a:r>
             <a:endParaRPr lang="en-US" sz="1000" dirty="0"/>
           </a:p>
@@ -16740,7 +16729,7 @@
         </p:nvSpPr>
         <p:spPr>
           <a:xfrm>
-            <a:off x="5943600" y="2930652"/>
+            <a:off x="5943600" y="3255264"/>
             <a:ext cx="5650992" cy="324612"/>
           </a:xfrm>
           <a:prstGeom prst="rect">
@@ -16765,8 +16754,8 @@
         </p:nvSpPr>
         <p:spPr>
           <a:xfrm>
-            <a:off x="6053328" y="2930652"/>
-            <a:ext cx="2760158" cy="324612"/>
+            <a:off x="6053328" y="3255264"/>
+            <a:ext cx="3024632" cy="324612"/>
           </a:xfrm>
           <a:prstGeom prst="rect">
             <a:avLst/>
@@ -16790,7 +16779,7 @@
                 <a:ea typeface="Calibri" pitchFamily="34" charset="-122"/>
                 <a:cs typeface="Calibri" pitchFamily="34" charset="-120"/>
               </a:rPr>
-              <a:t>16740 E. Ave of the Fountains — AZ</a:t>
+              <a:t>Sycamore Park — North Corktown</a:t>
             </a:r>
             <a:endParaRPr lang="en-US" sz="1000" dirty="0"/>
           </a:p>
@@ -16804,8 +16793,8 @@
         </p:nvSpPr>
         <p:spPr>
           <a:xfrm>
-            <a:off x="9032942" y="2930652"/>
-            <a:ext cx="1321724" cy="324612"/>
+            <a:off x="9297416" y="3255264"/>
+            <a:ext cx="1193292" cy="324612"/>
           </a:xfrm>
           <a:prstGeom prst="rect">
             <a:avLst/>
@@ -16843,8 +16832,8 @@
         </p:nvSpPr>
         <p:spPr>
           <a:xfrm>
-            <a:off x="10574122" y="2930652"/>
-            <a:ext cx="910742" cy="324612"/>
+            <a:off x="10710164" y="3255264"/>
+            <a:ext cx="774700" cy="324612"/>
           </a:xfrm>
           <a:prstGeom prst="rect">
             <a:avLst/>
@@ -16868,7 +16857,7 @@
                 <a:ea typeface="Calibri" pitchFamily="34" charset="-122"/>
                 <a:cs typeface="Calibri" pitchFamily="34" charset="-120"/>
               </a:rPr>
-              <a:t>9</a:t>
+              <a:t>10</a:t>
             </a:r>
             <a:endParaRPr lang="en-US" sz="1000" dirty="0"/>
           </a:p>
@@ -16882,7 +16871,7 @@
         </p:nvSpPr>
         <p:spPr>
           <a:xfrm>
-            <a:off x="5943600" y="3255264"/>
+            <a:off x="5943600" y="3579876"/>
             <a:ext cx="5650992" cy="324612"/>
           </a:xfrm>
           <a:prstGeom prst="rect">
@@ -16907,8 +16896,8 @@
         </p:nvSpPr>
         <p:spPr>
           <a:xfrm>
-            <a:off x="6053328" y="3255264"/>
-            <a:ext cx="2760158" cy="324612"/>
+            <a:off x="6053328" y="3579876"/>
+            <a:ext cx="3024632" cy="324612"/>
           </a:xfrm>
           <a:prstGeom prst="rect">
             <a:avLst/>
@@ -16932,7 +16921,7 @@
                 <a:ea typeface="Calibri" pitchFamily="34" charset="-122"/>
                 <a:cs typeface="Calibri" pitchFamily="34" charset="-120"/>
               </a:rPr>
-              <a:t>4142 4th St — Detroit</a:t>
+              <a:t>2221 &amp; 2225 Wabash — Detroit</a:t>
             </a:r>
             <a:endParaRPr lang="en-US" sz="1000" dirty="0"/>
           </a:p>
@@ -16946,8 +16935,8 @@
         </p:nvSpPr>
         <p:spPr>
           <a:xfrm>
-            <a:off x="9032942" y="3255264"/>
-            <a:ext cx="1321724" cy="324612"/>
+            <a:off x="9297416" y="3579876"/>
+            <a:ext cx="1193292" cy="324612"/>
           </a:xfrm>
           <a:prstGeom prst="rect">
             <a:avLst/>
@@ -16971,7 +16960,7 @@
                 <a:ea typeface="Calibri" pitchFamily="34" charset="-122"/>
                 <a:cs typeface="Calibri" pitchFamily="34" charset="-120"/>
               </a:rPr>
-              <a:t>Custom home</a:t>
+              <a:t>Multi</a:t>
             </a:r>
             <a:endParaRPr lang="en-US" sz="1000" dirty="0"/>
           </a:p>
@@ -16985,8 +16974,8 @@
         </p:nvSpPr>
         <p:spPr>
           <a:xfrm>
-            <a:off x="10574122" y="3255264"/>
-            <a:ext cx="910742" cy="324612"/>
+            <a:off x="10710164" y="3579876"/>
+            <a:ext cx="774700" cy="324612"/>
           </a:xfrm>
           <a:prstGeom prst="rect">
             <a:avLst/>
@@ -17010,7 +16999,7 @@
                 <a:ea typeface="Calibri" pitchFamily="34" charset="-122"/>
                 <a:cs typeface="Calibri" pitchFamily="34" charset="-120"/>
               </a:rPr>
-              <a:t>1</a:t>
+              <a:t>3</a:t>
             </a:r>
             <a:endParaRPr lang="en-US" sz="1000" dirty="0"/>
           </a:p>
@@ -17019,148 +17008,6 @@
       <p:sp>
         <p:nvSpPr>
           <p:cNvPr id="46" name="Shape 44"/>
-          <p:cNvSpPr/>
-          <p:nvPr/>
-        </p:nvSpPr>
-        <p:spPr>
-          <a:xfrm>
-            <a:off x="5943600" y="3579876"/>
-            <a:ext cx="5650992" cy="324612"/>
-          </a:xfrm>
-          <a:prstGeom prst="rect">
-            <a:avLst/>
-          </a:prstGeom>
-          <a:solidFill>
-            <a:srgbClr val="FFFFFF"/>
-          </a:solidFill>
-          <a:ln w="9525">
-            <a:solidFill>
-              <a:srgbClr val="E2E8E9"/>
-            </a:solidFill>
-            <a:prstDash val="solid"/>
-          </a:ln>
-        </p:spPr>
-      </p:sp>
-      <p:sp>
-        <p:nvSpPr>
-          <p:cNvPr id="47" name="Text 45"/>
-          <p:cNvSpPr/>
-          <p:nvPr/>
-        </p:nvSpPr>
-        <p:spPr>
-          <a:xfrm>
-            <a:off x="6053328" y="3579876"/>
-            <a:ext cx="2760158" cy="324612"/>
-          </a:xfrm>
-          <a:prstGeom prst="rect">
-            <a:avLst/>
-          </a:prstGeom>
-          <a:noFill/>
-          <a:ln/>
-        </p:spPr>
-        <p:txBody>
-          <a:bodyPr wrap="square" lIns="0" tIns="0" rIns="0" bIns="0" rtlCol="0" anchor="ctr"/>
-          <a:lstStyle/>
-          <a:p>
-            <a:pPr algn="l" indent="0" marL="0">
-              <a:buNone/>
-            </a:pPr>
-            <a:r>
-              <a:rPr lang="en-US" sz="1000" dirty="0">
-                <a:solidFill>
-                  <a:srgbClr val="12303C"/>
-                </a:solidFill>
-                <a:latin typeface="Calibri" pitchFamily="34" charset="0"/>
-                <a:ea typeface="Calibri" pitchFamily="34" charset="-122"/>
-                <a:cs typeface="Calibri" pitchFamily="34" charset="-120"/>
-              </a:rPr>
-              <a:t>5130 Trombley — Newport, MI</a:t>
-            </a:r>
-            <a:endParaRPr lang="en-US" sz="1000" dirty="0"/>
-          </a:p>
-        </p:txBody>
-      </p:sp>
-      <p:sp>
-        <p:nvSpPr>
-          <p:cNvPr id="48" name="Text 46"/>
-          <p:cNvSpPr/>
-          <p:nvPr/>
-        </p:nvSpPr>
-        <p:spPr>
-          <a:xfrm>
-            <a:off x="9032942" y="3579876"/>
-            <a:ext cx="1321724" cy="324612"/>
-          </a:xfrm>
-          <a:prstGeom prst="rect">
-            <a:avLst/>
-          </a:prstGeom>
-          <a:noFill/>
-          <a:ln/>
-        </p:spPr>
-        <p:txBody>
-          <a:bodyPr wrap="square" lIns="0" tIns="0" rIns="0" bIns="0" rtlCol="0" anchor="ctr"/>
-          <a:lstStyle/>
-          <a:p>
-            <a:pPr algn="r" indent="0" marL="0">
-              <a:buNone/>
-            </a:pPr>
-            <a:r>
-              <a:rPr lang="en-US" sz="1000" dirty="0">
-                <a:solidFill>
-                  <a:srgbClr val="47606B"/>
-                </a:solidFill>
-                <a:latin typeface="Calibri" pitchFamily="34" charset="0"/>
-                <a:ea typeface="Calibri" pitchFamily="34" charset="-122"/>
-                <a:cs typeface="Calibri" pitchFamily="34" charset="-120"/>
-              </a:rPr>
-              <a:t>Custom home</a:t>
-            </a:r>
-            <a:endParaRPr lang="en-US" sz="1000" dirty="0"/>
-          </a:p>
-        </p:txBody>
-      </p:sp>
-      <p:sp>
-        <p:nvSpPr>
-          <p:cNvPr id="49" name="Text 47"/>
-          <p:cNvSpPr/>
-          <p:nvPr/>
-        </p:nvSpPr>
-        <p:spPr>
-          <a:xfrm>
-            <a:off x="10574122" y="3579876"/>
-            <a:ext cx="910742" cy="324612"/>
-          </a:xfrm>
-          <a:prstGeom prst="rect">
-            <a:avLst/>
-          </a:prstGeom>
-          <a:noFill/>
-          <a:ln/>
-        </p:spPr>
-        <p:txBody>
-          <a:bodyPr wrap="square" lIns="0" tIns="0" rIns="0" bIns="0" rtlCol="0" anchor="ctr"/>
-          <a:lstStyle/>
-          <a:p>
-            <a:pPr algn="r" indent="0" marL="0">
-              <a:buNone/>
-            </a:pPr>
-            <a:r>
-              <a:rPr lang="en-US" sz="1000" dirty="0">
-                <a:solidFill>
-                  <a:srgbClr val="47606B"/>
-                </a:solidFill>
-                <a:latin typeface="Calibri" pitchFamily="34" charset="0"/>
-                <a:ea typeface="Calibri" pitchFamily="34" charset="-122"/>
-                <a:cs typeface="Calibri" pitchFamily="34" charset="-120"/>
-              </a:rPr>
-              <a:t>1</a:t>
-            </a:r>
-            <a:endParaRPr lang="en-US" sz="1000" dirty="0"/>
-          </a:p>
-        </p:txBody>
-      </p:sp>
-      <p:sp>
-        <p:nvSpPr>
-          <p:cNvPr id="50" name="Shape 48"/>
           <p:cNvSpPr/>
           <p:nvPr/>
         </p:nvSpPr>
@@ -17185,14 +17032,14 @@
       </p:sp>
       <p:sp>
         <p:nvSpPr>
-          <p:cNvPr id="51" name="Text 49"/>
+          <p:cNvPr id="47" name="Text 45"/>
           <p:cNvSpPr/>
           <p:nvPr/>
         </p:nvSpPr>
         <p:spPr>
           <a:xfrm>
             <a:off x="6053328" y="3904488"/>
-            <a:ext cx="2760158" cy="324612"/>
+            <a:ext cx="3024632" cy="324612"/>
           </a:xfrm>
           <a:prstGeom prst="rect">
             <a:avLst/>
@@ -17216,7 +17063,7 @@
                 <a:ea typeface="Calibri" pitchFamily="34" charset="-122"/>
                 <a:cs typeface="Calibri" pitchFamily="34" charset="-120"/>
               </a:rPr>
-              <a:t>Total in development</a:t>
+              <a:t>Total delivered</a:t>
             </a:r>
             <a:endParaRPr lang="en-US" sz="1000" dirty="0"/>
           </a:p>
@@ -17224,14 +17071,14 @@
       </p:sp>
       <p:sp>
         <p:nvSpPr>
-          <p:cNvPr id="52" name="Text 50"/>
-          <p:cNvSpPr/>
-          <p:nvPr/>
-        </p:nvSpPr>
-        <p:spPr>
-          <a:xfrm>
-            <a:off x="9032942" y="3904488"/>
-            <a:ext cx="1321724" cy="324612"/>
+          <p:cNvPr id="48" name="Text 46"/>
+          <p:cNvSpPr/>
+          <p:nvPr/>
+        </p:nvSpPr>
+        <p:spPr>
+          <a:xfrm>
+            <a:off x="9297416" y="3904488"/>
+            <a:ext cx="1193292" cy="324612"/>
           </a:xfrm>
           <a:prstGeom prst="rect">
             <a:avLst/>
@@ -17263,14 +17110,14 @@
       </p:sp>
       <p:sp>
         <p:nvSpPr>
-          <p:cNvPr id="53" name="Text 51"/>
-          <p:cNvSpPr/>
-          <p:nvPr/>
-        </p:nvSpPr>
-        <p:spPr>
-          <a:xfrm>
-            <a:off x="10574122" y="3904488"/>
-            <a:ext cx="910742" cy="324612"/>
+          <p:cNvPr id="49" name="Text 47"/>
+          <p:cNvSpPr/>
+          <p:nvPr/>
+        </p:nvSpPr>
+        <p:spPr>
+          <a:xfrm>
+            <a:off x="10710164" y="3904488"/>
+            <a:ext cx="774700" cy="324612"/>
           </a:xfrm>
           <a:prstGeom prst="rect">
             <a:avLst/>
@@ -17294,7 +17141,7 @@
                 <a:ea typeface="Calibri" pitchFamily="34" charset="-122"/>
                 <a:cs typeface="Calibri" pitchFamily="34" charset="-120"/>
               </a:rPr>
-              <a:t>47</a:t>
+              <a:t>80</a:t>
             </a:r>
             <a:endParaRPr lang="en-US" sz="1000" dirty="0"/>
           </a:p>
@@ -17302,7 +17149,7 @@
       </p:sp>
       <p:sp>
         <p:nvSpPr>
-          <p:cNvPr id="54" name="Text 52"/>
+          <p:cNvPr id="50" name="Text 48"/>
           <p:cNvSpPr/>
           <p:nvPr/>
         </p:nvSpPr>
@@ -17336,7 +17183,7 @@
                 <a:ea typeface="Calibri" pitchFamily="34" charset="-122"/>
                 <a:cs typeface="Calibri" pitchFamily="34" charset="-120"/>
               </a:rPr>
-              <a:t>Source: Bondy Construction &amp; Design real-estate-owned and experience schedule, 21 March 2026. Banking reference: First Merchants Bank has financed $10M+ of Bondy projects since 2019, with all obligations met per terms — reference letter available on request.</a:t>
+              <a:t>Source: Bondy Construction &amp; Design firm profile, July 2026. Banking reference: First Merchants Bank has financed $10M+ of Bondy projects since 2019, with all obligations met per terms — reference letter available on request.</a:t>
             </a:r>
             <a:endParaRPr lang="en-US" sz="850" dirty="0"/>
           </a:p>
@@ -17344,7 +17191,7 @@
       </p:sp>
       <p:sp>
         <p:nvSpPr>
-          <p:cNvPr id="55" name="Text 53"/>
+          <p:cNvPr id="51" name="Text 49"/>
           <p:cNvSpPr/>
           <p:nvPr/>
         </p:nvSpPr>
@@ -17383,7 +17230,7 @@
       </p:sp>
       <p:sp>
         <p:nvSpPr>
-          <p:cNvPr id="56" name="Text 54"/>
+          <p:cNvPr id="52" name="Text 50"/>
           <p:cNvSpPr/>
           <p:nvPr/>
         </p:nvSpPr>

</xml_diff>

<commit_message>
Show the underwriting cushion: 6% secured against 9% carried
The construction debt is secured at 6% but the proforma is underwritten at
9% with overage allowances in the budget, so the projected margin is
modeled three points above the debt cost actually in hand. That was
invisible in the deck.

- Adds a 6% / 9% band across the foot of the financials slide, directly
  under the proforma the cushion applies to.
- Names the secured rate in the Phase 1 capital stack and in the Phase 1
  bullet where the construction loan is first mentioned.
- Tightens the proforma table and stat cards to make room for the band.

Co-Authored-By: Claude Opus 5 <noreply@anthropic.com>
Claude-Session: https://claude.ai/code/session_01CYAVPhQRHuvkVD16PJtbYL
</commit_message>
<xml_diff>
--- a/deck/3331-Trumbull-Investor-Deck-Aug-2026.pptx
+++ b/deck/3331-Trumbull-Investor-Deck-Aug-2026.pptx
@@ -5966,7 +5966,7 @@
                 <a:ea typeface="Calibri" pitchFamily="34" charset="-122"/>
                 <a:cs typeface="Calibri" pitchFamily="34" charset="-120"/>
               </a:rPr>
-              <a:t>Funded by a First Merchants construction loan alongside the $700,000 investor note tranche</a:t>
+              <a:t>Funded by a First Merchants construction loan — secured at 6% — alongside the $700,000 investor note tranche</a:t>
             </a:r>
             <a:endParaRPr lang="en-US" sz="1050" dirty="0"/>
           </a:p>
@@ -8483,7 +8483,7 @@
                 <a:ea typeface="Calibri" pitchFamily="34" charset="-122"/>
                 <a:cs typeface="Calibri" pitchFamily="34" charset="-120"/>
               </a:rPr>
-              <a:t>First Merchants Bank</a:t>
+              <a:t>First Merchants Bank · secured at 6%</a:t>
             </a:r>
             <a:endParaRPr lang="en-US" sz="950" dirty="0"/>
           </a:p>
@@ -11942,7 +11942,7 @@
         </p:nvSpPr>
         <p:spPr>
           <a:xfrm>
-            <a:off x="566928" y="1591056"/>
+            <a:off x="566928" y="1536192"/>
             <a:ext cx="6492240" cy="292608"/>
           </a:xfrm>
           <a:prstGeom prst="rect">
@@ -11967,7 +11967,7 @@
         </p:nvSpPr>
         <p:spPr>
           <a:xfrm>
-            <a:off x="676656" y="1591056"/>
+            <a:off x="676656" y="1536192"/>
             <a:ext cx="4296885" cy="292608"/>
           </a:xfrm>
           <a:prstGeom prst="rect">
@@ -12006,7 +12006,7 @@
         </p:nvSpPr>
         <p:spPr>
           <a:xfrm>
-            <a:off x="5192997" y="1591056"/>
+            <a:off x="5192997" y="1536192"/>
             <a:ext cx="1756443" cy="292608"/>
           </a:xfrm>
           <a:prstGeom prst="rect">
@@ -12045,8 +12045,8 @@
         </p:nvSpPr>
         <p:spPr>
           <a:xfrm>
-            <a:off x="566928" y="1883664"/>
-            <a:ext cx="6492240" cy="384048"/>
+            <a:off x="566928" y="1828800"/>
+            <a:ext cx="6492240" cy="365760"/>
           </a:xfrm>
           <a:prstGeom prst="rect">
             <a:avLst/>
@@ -12070,8 +12070,8 @@
         </p:nvSpPr>
         <p:spPr>
           <a:xfrm>
-            <a:off x="676656" y="1883664"/>
-            <a:ext cx="4296885" cy="384048"/>
+            <a:off x="676656" y="1828800"/>
+            <a:ext cx="4296885" cy="365760"/>
           </a:xfrm>
           <a:prstGeom prst="rect">
             <a:avLst/>
@@ -12109,8 +12109,8 @@
         </p:nvSpPr>
         <p:spPr>
           <a:xfrm>
-            <a:off x="5192997" y="1883664"/>
-            <a:ext cx="1756443" cy="384048"/>
+            <a:off x="5192997" y="1828800"/>
+            <a:ext cx="1756443" cy="365760"/>
           </a:xfrm>
           <a:prstGeom prst="rect">
             <a:avLst/>
@@ -12148,8 +12148,8 @@
         </p:nvSpPr>
         <p:spPr>
           <a:xfrm>
-            <a:off x="566928" y="2267712"/>
-            <a:ext cx="6492240" cy="384048"/>
+            <a:off x="566928" y="2194560"/>
+            <a:ext cx="6492240" cy="365760"/>
           </a:xfrm>
           <a:prstGeom prst="rect">
             <a:avLst/>
@@ -12173,8 +12173,8 @@
         </p:nvSpPr>
         <p:spPr>
           <a:xfrm>
-            <a:off x="676656" y="2267712"/>
-            <a:ext cx="4296885" cy="384048"/>
+            <a:off x="676656" y="2194560"/>
+            <a:ext cx="4296885" cy="365760"/>
           </a:xfrm>
           <a:prstGeom prst="rect">
             <a:avLst/>
@@ -12212,8 +12212,8 @@
         </p:nvSpPr>
         <p:spPr>
           <a:xfrm>
-            <a:off x="5192997" y="2267712"/>
-            <a:ext cx="1756443" cy="384048"/>
+            <a:off x="5192997" y="2194560"/>
+            <a:ext cx="1756443" cy="365760"/>
           </a:xfrm>
           <a:prstGeom prst="rect">
             <a:avLst/>
@@ -12251,8 +12251,8 @@
         </p:nvSpPr>
         <p:spPr>
           <a:xfrm>
-            <a:off x="566928" y="2651760"/>
-            <a:ext cx="6492240" cy="384048"/>
+            <a:off x="566928" y="2560320"/>
+            <a:ext cx="6492240" cy="365760"/>
           </a:xfrm>
           <a:prstGeom prst="rect">
             <a:avLst/>
@@ -12276,8 +12276,8 @@
         </p:nvSpPr>
         <p:spPr>
           <a:xfrm>
-            <a:off x="676656" y="2651760"/>
-            <a:ext cx="4296885" cy="384048"/>
+            <a:off x="676656" y="2560320"/>
+            <a:ext cx="4296885" cy="365760"/>
           </a:xfrm>
           <a:prstGeom prst="rect">
             <a:avLst/>
@@ -12315,8 +12315,8 @@
         </p:nvSpPr>
         <p:spPr>
           <a:xfrm>
-            <a:off x="5192997" y="2651760"/>
-            <a:ext cx="1756443" cy="384048"/>
+            <a:off x="5192997" y="2560320"/>
+            <a:ext cx="1756443" cy="365760"/>
           </a:xfrm>
           <a:prstGeom prst="rect">
             <a:avLst/>
@@ -12354,8 +12354,8 @@
         </p:nvSpPr>
         <p:spPr>
           <a:xfrm>
-            <a:off x="566928" y="3035808"/>
-            <a:ext cx="6492240" cy="384048"/>
+            <a:off x="566928" y="2926080"/>
+            <a:ext cx="6492240" cy="365760"/>
           </a:xfrm>
           <a:prstGeom prst="rect">
             <a:avLst/>
@@ -12379,8 +12379,8 @@
         </p:nvSpPr>
         <p:spPr>
           <a:xfrm>
-            <a:off x="676656" y="3035808"/>
-            <a:ext cx="4296885" cy="384048"/>
+            <a:off x="676656" y="2926080"/>
+            <a:ext cx="4296885" cy="365760"/>
           </a:xfrm>
           <a:prstGeom prst="rect">
             <a:avLst/>
@@ -12418,8 +12418,8 @@
         </p:nvSpPr>
         <p:spPr>
           <a:xfrm>
-            <a:off x="5192997" y="3035808"/>
-            <a:ext cx="1756443" cy="384048"/>
+            <a:off x="5192997" y="2926080"/>
+            <a:ext cx="1756443" cy="365760"/>
           </a:xfrm>
           <a:prstGeom prst="rect">
             <a:avLst/>
@@ -12457,8 +12457,8 @@
         </p:nvSpPr>
         <p:spPr>
           <a:xfrm>
-            <a:off x="566928" y="3419856"/>
-            <a:ext cx="6492240" cy="384048"/>
+            <a:off x="566928" y="3291840"/>
+            <a:ext cx="6492240" cy="365760"/>
           </a:xfrm>
           <a:prstGeom prst="rect">
             <a:avLst/>
@@ -12482,8 +12482,8 @@
         </p:nvSpPr>
         <p:spPr>
           <a:xfrm>
-            <a:off x="676656" y="3419856"/>
-            <a:ext cx="4296885" cy="384048"/>
+            <a:off x="676656" y="3291840"/>
+            <a:ext cx="4296885" cy="365760"/>
           </a:xfrm>
           <a:prstGeom prst="rect">
             <a:avLst/>
@@ -12521,8 +12521,8 @@
         </p:nvSpPr>
         <p:spPr>
           <a:xfrm>
-            <a:off x="5192997" y="3419856"/>
-            <a:ext cx="1756443" cy="384048"/>
+            <a:off x="5192997" y="3291840"/>
+            <a:ext cx="1756443" cy="365760"/>
           </a:xfrm>
           <a:prstGeom prst="rect">
             <a:avLst/>
@@ -12560,8 +12560,8 @@
         </p:nvSpPr>
         <p:spPr>
           <a:xfrm>
-            <a:off x="566928" y="3803904"/>
-            <a:ext cx="6492240" cy="384048"/>
+            <a:off x="566928" y="3657600"/>
+            <a:ext cx="6492240" cy="365760"/>
           </a:xfrm>
           <a:prstGeom prst="rect">
             <a:avLst/>
@@ -12585,8 +12585,8 @@
         </p:nvSpPr>
         <p:spPr>
           <a:xfrm>
-            <a:off x="676656" y="3803904"/>
-            <a:ext cx="4296885" cy="384048"/>
+            <a:off x="676656" y="3657600"/>
+            <a:ext cx="4296885" cy="365760"/>
           </a:xfrm>
           <a:prstGeom prst="rect">
             <a:avLst/>
@@ -12624,8 +12624,8 @@
         </p:nvSpPr>
         <p:spPr>
           <a:xfrm>
-            <a:off x="5192997" y="3803904"/>
-            <a:ext cx="1756443" cy="384048"/>
+            <a:off x="5192997" y="3657600"/>
+            <a:ext cx="1756443" cy="365760"/>
           </a:xfrm>
           <a:prstGeom prst="rect">
             <a:avLst/>
@@ -12663,8 +12663,8 @@
         </p:nvSpPr>
         <p:spPr>
           <a:xfrm>
-            <a:off x="566928" y="4187952"/>
-            <a:ext cx="6492240" cy="384048"/>
+            <a:off x="566928" y="4023360"/>
+            <a:ext cx="6492240" cy="365760"/>
           </a:xfrm>
           <a:prstGeom prst="rect">
             <a:avLst/>
@@ -12688,8 +12688,8 @@
         </p:nvSpPr>
         <p:spPr>
           <a:xfrm>
-            <a:off x="676656" y="4187952"/>
-            <a:ext cx="4296885" cy="384048"/>
+            <a:off x="676656" y="4023360"/>
+            <a:ext cx="4296885" cy="365760"/>
           </a:xfrm>
           <a:prstGeom prst="rect">
             <a:avLst/>
@@ -12727,8 +12727,8 @@
         </p:nvSpPr>
         <p:spPr>
           <a:xfrm>
-            <a:off x="5192997" y="4187952"/>
-            <a:ext cx="1756443" cy="384048"/>
+            <a:off x="5192997" y="4023360"/>
+            <a:ext cx="1756443" cy="365760"/>
           </a:xfrm>
           <a:prstGeom prst="rect">
             <a:avLst/>
@@ -12766,7 +12766,7 @@
         </p:nvSpPr>
         <p:spPr>
           <a:xfrm>
-            <a:off x="566928" y="4718304"/>
+            <a:off x="566928" y="4498848"/>
             <a:ext cx="6492240" cy="475488"/>
           </a:xfrm>
           <a:prstGeom prst="rect">
@@ -12808,8 +12808,8 @@
         </p:nvSpPr>
         <p:spPr>
           <a:xfrm>
-            <a:off x="7443216" y="1591056"/>
-            <a:ext cx="2011680" cy="1426464"/>
+            <a:off x="7443216" y="1536192"/>
+            <a:ext cx="2011680" cy="1389888"/>
           </a:xfrm>
           <a:prstGeom prst="rect">
             <a:avLst/>
@@ -12840,7 +12840,7 @@
         </p:nvSpPr>
         <p:spPr>
           <a:xfrm>
-            <a:off x="7644384" y="1773936"/>
+            <a:off x="7644384" y="1719072"/>
             <a:ext cx="82296" cy="82296"/>
           </a:xfrm>
           <a:prstGeom prst="rect">
@@ -12860,7 +12860,7 @@
         </p:nvSpPr>
         <p:spPr>
           <a:xfrm>
-            <a:off x="7644384" y="1883664"/>
+            <a:off x="7644384" y="1828800"/>
             <a:ext cx="1645920" cy="384048"/>
           </a:xfrm>
           <a:prstGeom prst="rect">
@@ -12899,8 +12899,8 @@
         </p:nvSpPr>
         <p:spPr>
           <a:xfrm>
-            <a:off x="7644384" y="2267712"/>
-            <a:ext cx="1645920" cy="658368"/>
+            <a:off x="7644384" y="2212848"/>
+            <a:ext cx="1645920" cy="621792"/>
           </a:xfrm>
           <a:prstGeom prst="rect">
             <a:avLst/>
@@ -12961,8 +12961,8 @@
         </p:nvSpPr>
         <p:spPr>
           <a:xfrm>
-            <a:off x="9582912" y="1591056"/>
-            <a:ext cx="2011680" cy="1426464"/>
+            <a:off x="9582912" y="1536192"/>
+            <a:ext cx="2011680" cy="1389888"/>
           </a:xfrm>
           <a:prstGeom prst="rect">
             <a:avLst/>
@@ -12993,7 +12993,7 @@
         </p:nvSpPr>
         <p:spPr>
           <a:xfrm>
-            <a:off x="9784080" y="1773936"/>
+            <a:off x="9784080" y="1719072"/>
             <a:ext cx="82296" cy="82296"/>
           </a:xfrm>
           <a:prstGeom prst="rect">
@@ -13013,7 +13013,7 @@
         </p:nvSpPr>
         <p:spPr>
           <a:xfrm>
-            <a:off x="9784080" y="1883664"/>
+            <a:off x="9784080" y="1828800"/>
             <a:ext cx="1645920" cy="384048"/>
           </a:xfrm>
           <a:prstGeom prst="rect">
@@ -13052,8 +13052,8 @@
         </p:nvSpPr>
         <p:spPr>
           <a:xfrm>
-            <a:off x="9784080" y="2267712"/>
-            <a:ext cx="1645920" cy="658368"/>
+            <a:off x="9784080" y="2212848"/>
+            <a:ext cx="1645920" cy="621792"/>
           </a:xfrm>
           <a:prstGeom prst="rect">
             <a:avLst/>
@@ -13114,8 +13114,8 @@
         </p:nvSpPr>
         <p:spPr>
           <a:xfrm>
-            <a:off x="7443216" y="3145536"/>
-            <a:ext cx="2011680" cy="1426464"/>
+            <a:off x="7443216" y="3054096"/>
+            <a:ext cx="2011680" cy="1389888"/>
           </a:xfrm>
           <a:prstGeom prst="rect">
             <a:avLst/>
@@ -13146,7 +13146,7 @@
         </p:nvSpPr>
         <p:spPr>
           <a:xfrm>
-            <a:off x="7644384" y="3328416"/>
+            <a:off x="7644384" y="3236976"/>
             <a:ext cx="82296" cy="82296"/>
           </a:xfrm>
           <a:prstGeom prst="rect">
@@ -13166,7 +13166,7 @@
         </p:nvSpPr>
         <p:spPr>
           <a:xfrm>
-            <a:off x="7644384" y="3438144"/>
+            <a:off x="7644384" y="3346704"/>
             <a:ext cx="1645920" cy="384048"/>
           </a:xfrm>
           <a:prstGeom prst="rect">
@@ -13205,8 +13205,8 @@
         </p:nvSpPr>
         <p:spPr>
           <a:xfrm>
-            <a:off x="7644384" y="3822192"/>
-            <a:ext cx="1645920" cy="658368"/>
+            <a:off x="7644384" y="3730752"/>
+            <a:ext cx="1645920" cy="621792"/>
           </a:xfrm>
           <a:prstGeom prst="rect">
             <a:avLst/>
@@ -13267,8 +13267,8 @@
         </p:nvSpPr>
         <p:spPr>
           <a:xfrm>
-            <a:off x="9582912" y="3145536"/>
-            <a:ext cx="2011680" cy="1426464"/>
+            <a:off x="9582912" y="3054096"/>
+            <a:ext cx="2011680" cy="1389888"/>
           </a:xfrm>
           <a:prstGeom prst="rect">
             <a:avLst/>
@@ -13299,7 +13299,7 @@
         </p:nvSpPr>
         <p:spPr>
           <a:xfrm>
-            <a:off x="9784080" y="3328416"/>
+            <a:off x="9784080" y="3236976"/>
             <a:ext cx="82296" cy="82296"/>
           </a:xfrm>
           <a:prstGeom prst="rect">
@@ -13319,7 +13319,7 @@
         </p:nvSpPr>
         <p:spPr>
           <a:xfrm>
-            <a:off x="9784080" y="3438144"/>
+            <a:off x="9784080" y="3346704"/>
             <a:ext cx="1645920" cy="384048"/>
           </a:xfrm>
           <a:prstGeom prst="rect">
@@ -13358,8 +13358,8 @@
         </p:nvSpPr>
         <p:spPr>
           <a:xfrm>
-            <a:off x="9784080" y="3822192"/>
-            <a:ext cx="1645920" cy="658368"/>
+            <a:off x="9784080" y="3730752"/>
+            <a:ext cx="1645920" cy="621792"/>
           </a:xfrm>
           <a:prstGeom prst="rect">
             <a:avLst/>
@@ -13414,7 +13414,276 @@
       </p:sp>
       <p:sp>
         <p:nvSpPr>
-          <p:cNvPr id="46" name="Text 44"/>
+          <p:cNvPr id="46" name="Shape 44"/>
+          <p:cNvSpPr/>
+          <p:nvPr/>
+        </p:nvSpPr>
+        <p:spPr>
+          <a:xfrm>
+            <a:off x="566928" y="5102352"/>
+            <a:ext cx="11045952" cy="1060704"/>
+          </a:xfrm>
+          <a:prstGeom prst="rect">
+            <a:avLst/>
+          </a:prstGeom>
+          <a:solidFill>
+            <a:srgbClr val="12303C"/>
+          </a:solidFill>
+          <a:ln w="15875">
+            <a:solidFill>
+              <a:srgbClr val="D9A441"/>
+            </a:solidFill>
+            <a:prstDash val="solid"/>
+          </a:ln>
+        </p:spPr>
+      </p:sp>
+      <p:sp>
+        <p:nvSpPr>
+          <p:cNvPr id="47" name="Text 45"/>
+          <p:cNvSpPr/>
+          <p:nvPr/>
+        </p:nvSpPr>
+        <p:spPr>
+          <a:xfrm>
+            <a:off x="877824" y="5266944"/>
+            <a:ext cx="1371600" cy="438912"/>
+          </a:xfrm>
+          <a:prstGeom prst="rect">
+            <a:avLst/>
+          </a:prstGeom>
+          <a:noFill/>
+          <a:ln/>
+        </p:spPr>
+        <p:txBody>
+          <a:bodyPr wrap="square" lIns="0" tIns="0" rIns="0" bIns="0" rtlCol="0" anchor="ctr"/>
+          <a:lstStyle/>
+          <a:p>
+            <a:pPr indent="0" marL="0">
+              <a:buNone/>
+            </a:pPr>
+            <a:r>
+              <a:rPr lang="en-US" sz="2900" b="1" dirty="0">
+                <a:solidFill>
+                  <a:srgbClr val="E3C581"/>
+                </a:solidFill>
+                <a:latin typeface="Cambria" pitchFamily="34" charset="0"/>
+                <a:ea typeface="Cambria" pitchFamily="34" charset="-122"/>
+                <a:cs typeface="Cambria" pitchFamily="34" charset="-120"/>
+              </a:rPr>
+              <a:t>6%</a:t>
+            </a:r>
+            <a:endParaRPr lang="en-US" sz="2900" dirty="0"/>
+          </a:p>
+        </p:txBody>
+      </p:sp>
+      <p:sp>
+        <p:nvSpPr>
+          <p:cNvPr id="48" name="Text 46"/>
+          <p:cNvSpPr/>
+          <p:nvPr/>
+        </p:nvSpPr>
+        <p:spPr>
+          <a:xfrm>
+            <a:off x="877824" y="5705856"/>
+            <a:ext cx="1828800" cy="347472"/>
+          </a:xfrm>
+          <a:prstGeom prst="rect">
+            <a:avLst/>
+          </a:prstGeom>
+          <a:noFill/>
+          <a:ln/>
+        </p:spPr>
+        <p:txBody>
+          <a:bodyPr wrap="square" lIns="0" tIns="0" rIns="0" bIns="0" rtlCol="0" anchor="t"/>
+          <a:lstStyle/>
+          <a:p>
+            <a:pPr indent="0" marL="0">
+              <a:lnSpc>
+                <a:spcPts val="1000"/>
+              </a:lnSpc>
+              <a:buNone/>
+            </a:pPr>
+            <a:r>
+              <a:rPr lang="en-US" sz="800" b="1" spc="70" kern="0" dirty="0">
+                <a:solidFill>
+                  <a:srgbClr val="FFFFFF"/>
+                </a:solidFill>
+                <a:latin typeface="Calibri" pitchFamily="34" charset="0"/>
+                <a:ea typeface="Calibri" pitchFamily="34" charset="-122"/>
+                <a:cs typeface="Calibri" pitchFamily="34" charset="-120"/>
+              </a:rPr>
+              <a:t>CONSTRUCTION DEBT</a:t>
+            </a:r>
+            <a:endParaRPr lang="en-US" sz="800" dirty="0"/>
+          </a:p>
+          <a:p>
+            <a:pPr indent="0" marL="0">
+              <a:lnSpc>
+                <a:spcPts val="1000"/>
+              </a:lnSpc>
+              <a:buNone/>
+            </a:pPr>
+            <a:r>
+              <a:rPr lang="en-US" sz="800" b="1" spc="70" kern="0" dirty="0">
+                <a:solidFill>
+                  <a:srgbClr val="FFFFFF"/>
+                </a:solidFill>
+                <a:latin typeface="Calibri" pitchFamily="34" charset="0"/>
+                <a:ea typeface="Calibri" pitchFamily="34" charset="-122"/>
+                <a:cs typeface="Calibri" pitchFamily="34" charset="-120"/>
+              </a:rPr>
+              <a:t>SECURED</a:t>
+            </a:r>
+            <a:endParaRPr lang="en-US" sz="800" dirty="0"/>
+          </a:p>
+        </p:txBody>
+      </p:sp>
+      <p:sp>
+        <p:nvSpPr>
+          <p:cNvPr id="49" name="Text 47"/>
+          <p:cNvSpPr/>
+          <p:nvPr/>
+        </p:nvSpPr>
+        <p:spPr>
+          <a:xfrm>
+            <a:off x="2962656" y="5266944"/>
+            <a:ext cx="1371600" cy="438912"/>
+          </a:xfrm>
+          <a:prstGeom prst="rect">
+            <a:avLst/>
+          </a:prstGeom>
+          <a:noFill/>
+          <a:ln/>
+        </p:spPr>
+        <p:txBody>
+          <a:bodyPr wrap="square" lIns="0" tIns="0" rIns="0" bIns="0" rtlCol="0" anchor="ctr"/>
+          <a:lstStyle/>
+          <a:p>
+            <a:pPr indent="0" marL="0">
+              <a:buNone/>
+            </a:pPr>
+            <a:r>
+              <a:rPr lang="en-US" sz="2900" b="1" dirty="0">
+                <a:solidFill>
+                  <a:srgbClr val="FFFFFF"/>
+                </a:solidFill>
+                <a:latin typeface="Cambria" pitchFamily="34" charset="0"/>
+                <a:ea typeface="Cambria" pitchFamily="34" charset="-122"/>
+                <a:cs typeface="Cambria" pitchFamily="34" charset="-120"/>
+              </a:rPr>
+              <a:t>9%</a:t>
+            </a:r>
+            <a:endParaRPr lang="en-US" sz="2900" dirty="0"/>
+          </a:p>
+        </p:txBody>
+      </p:sp>
+      <p:sp>
+        <p:nvSpPr>
+          <p:cNvPr id="50" name="Text 48"/>
+          <p:cNvSpPr/>
+          <p:nvPr/>
+        </p:nvSpPr>
+        <p:spPr>
+          <a:xfrm>
+            <a:off x="2962656" y="5705856"/>
+            <a:ext cx="1828800" cy="347472"/>
+          </a:xfrm>
+          <a:prstGeom prst="rect">
+            <a:avLst/>
+          </a:prstGeom>
+          <a:noFill/>
+          <a:ln/>
+        </p:spPr>
+        <p:txBody>
+          <a:bodyPr wrap="square" lIns="0" tIns="0" rIns="0" bIns="0" rtlCol="0" anchor="t"/>
+          <a:lstStyle/>
+          <a:p>
+            <a:pPr indent="0" marL="0">
+              <a:lnSpc>
+                <a:spcPts val="1000"/>
+              </a:lnSpc>
+              <a:buNone/>
+            </a:pPr>
+            <a:r>
+              <a:rPr lang="en-US" sz="800" b="1" spc="70" kern="0" dirty="0">
+                <a:solidFill>
+                  <a:srgbClr val="9FC0C8"/>
+                </a:solidFill>
+                <a:latin typeface="Calibri" pitchFamily="34" charset="0"/>
+                <a:ea typeface="Calibri" pitchFamily="34" charset="-122"/>
+                <a:cs typeface="Calibri" pitchFamily="34" charset="-120"/>
+              </a:rPr>
+              <a:t>CARRIED IN THE</a:t>
+            </a:r>
+            <a:endParaRPr lang="en-US" sz="800" dirty="0"/>
+          </a:p>
+          <a:p>
+            <a:pPr indent="0" marL="0">
+              <a:lnSpc>
+                <a:spcPts val="1000"/>
+              </a:lnSpc>
+              <a:buNone/>
+            </a:pPr>
+            <a:r>
+              <a:rPr lang="en-US" sz="800" b="1" spc="70" kern="0" dirty="0">
+                <a:solidFill>
+                  <a:srgbClr val="9FC0C8"/>
+                </a:solidFill>
+                <a:latin typeface="Calibri" pitchFamily="34" charset="0"/>
+                <a:ea typeface="Calibri" pitchFamily="34" charset="-122"/>
+                <a:cs typeface="Calibri" pitchFamily="34" charset="-120"/>
+              </a:rPr>
+              <a:t>PROFORMA ABOVE</a:t>
+            </a:r>
+            <a:endParaRPr lang="en-US" sz="800" dirty="0"/>
+          </a:p>
+        </p:txBody>
+      </p:sp>
+      <p:sp>
+        <p:nvSpPr>
+          <p:cNvPr id="51" name="Text 49"/>
+          <p:cNvSpPr/>
+          <p:nvPr/>
+        </p:nvSpPr>
+        <p:spPr>
+          <a:xfrm>
+            <a:off x="5047488" y="5285232"/>
+            <a:ext cx="6309360" cy="731520"/>
+          </a:xfrm>
+          <a:prstGeom prst="rect">
+            <a:avLst/>
+          </a:prstGeom>
+          <a:noFill/>
+          <a:ln/>
+        </p:spPr>
+        <p:txBody>
+          <a:bodyPr wrap="square" lIns="0" tIns="0" rIns="0" bIns="0" rtlCol="0" anchor="ctr"/>
+          <a:lstStyle/>
+          <a:p>
+            <a:pPr indent="0" marL="0">
+              <a:lnSpc>
+                <a:spcPts val="1400"/>
+              </a:lnSpc>
+              <a:buNone/>
+            </a:pPr>
+            <a:r>
+              <a:rPr lang="en-US" sz="1050" dirty="0">
+                <a:solidFill>
+                  <a:srgbClr val="C6DADE"/>
+                </a:solidFill>
+                <a:latin typeface="Calibri" pitchFamily="34" charset="0"/>
+                <a:ea typeface="Calibri" pitchFamily="34" charset="-122"/>
+                <a:cs typeface="Calibri" pitchFamily="34" charset="-120"/>
+              </a:rPr>
+              <a:t>The construction loan is secured at 6%. Every figure above is underwritten at 9%, with construction overage allowances carried in the budget — so the projected margin is modeled three points above the debt cost actually in hand, before any of that cushion is counted.</a:t>
+            </a:r>
+            <a:endParaRPr lang="en-US" sz="1050" dirty="0"/>
+          </a:p>
+        </p:txBody>
+      </p:sp>
+      <p:sp>
+        <p:nvSpPr>
+          <p:cNvPr id="52" name="Text 50"/>
           <p:cNvSpPr/>
           <p:nvPr/>
         </p:nvSpPr>
@@ -13453,7 +13722,7 @@
       </p:sp>
       <p:sp>
         <p:nvSpPr>
-          <p:cNvPr id="47" name="Text 45"/>
+          <p:cNvPr id="53" name="Text 51"/>
           <p:cNvSpPr/>
           <p:nvPr/>
         </p:nvSpPr>

</xml_diff>

<commit_message>
Update Kevin Simpson's title to Co-Developer & Investor Relations
Applies on the sponsorship bio and the closing signature block, matching
the title already used on the Bondy track record exhibit. The signature
block now carries the title on its own line above the firm name.

Co-Authored-By: Claude Opus 5 <noreply@anthropic.com>
Claude-Session: https://claude.ai/code/session_01CYAVPhQRHuvkVD16PJtbYL
</commit_message>
<xml_diff>
--- a/deck/3331-Trumbull-Investor-Deck-Aug-2026.pptx
+++ b/deck/3331-Trumbull-Investor-Deck-Aug-2026.pptx
@@ -4495,7 +4495,7 @@
         </p:nvSpPr>
         <p:spPr>
           <a:xfrm>
-            <a:off x="566928" y="5376672"/>
+            <a:off x="566928" y="5340096"/>
             <a:ext cx="5394960" cy="256032"/>
           </a:xfrm>
           <a:prstGeom prst="rect">
@@ -4520,7 +4520,7 @@
                 <a:ea typeface="Calibri" pitchFamily="34" charset="-122"/>
                 <a:cs typeface="Calibri" pitchFamily="34" charset="-120"/>
               </a:rPr>
-              <a:t>Kevin Simpson  ·  AK Capital Investments LLC</a:t>
+              <a:t>Kevin Simpson  ·  Co-Developer &amp; Investor Relations</a:t>
             </a:r>
             <a:endParaRPr lang="en-US" sz="1200" dirty="0"/>
           </a:p>
@@ -4534,7 +4534,46 @@
         </p:nvSpPr>
         <p:spPr>
           <a:xfrm>
-            <a:off x="566928" y="5632704"/>
+            <a:off x="566928" y="5577840"/>
+            <a:ext cx="5394960" cy="219456"/>
+          </a:xfrm>
+          <a:prstGeom prst="rect">
+            <a:avLst/>
+          </a:prstGeom>
+          <a:noFill/>
+          <a:ln/>
+        </p:spPr>
+        <p:txBody>
+          <a:bodyPr wrap="square" lIns="0" tIns="0" rIns="0" bIns="0" rtlCol="0" anchor="ctr"/>
+          <a:lstStyle/>
+          <a:p>
+            <a:pPr indent="0" marL="0">
+              <a:buNone/>
+            </a:pPr>
+            <a:r>
+              <a:rPr lang="en-US" sz="1050" dirty="0">
+                <a:solidFill>
+                  <a:srgbClr val="9FC0C8"/>
+                </a:solidFill>
+                <a:latin typeface="Calibri" pitchFamily="34" charset="0"/>
+                <a:ea typeface="Calibri" pitchFamily="34" charset="-122"/>
+                <a:cs typeface="Calibri" pitchFamily="34" charset="-120"/>
+              </a:rPr>
+              <a:t>AK Capital Investments LLC</a:t>
+            </a:r>
+            <a:endParaRPr lang="en-US" sz="1050" dirty="0"/>
+          </a:p>
+        </p:txBody>
+      </p:sp>
+      <p:sp>
+        <p:nvSpPr>
+          <p:cNvPr id="20" name="Text 17"/>
+          <p:cNvSpPr/>
+          <p:nvPr/>
+        </p:nvSpPr>
+        <p:spPr>
+          <a:xfrm>
+            <a:off x="566928" y="5815584"/>
             <a:ext cx="5394960" cy="237744"/>
           </a:xfrm>
           <a:prstGeom prst="rect">
@@ -4567,14 +4606,14 @@
       </p:sp>
       <p:sp>
         <p:nvSpPr>
-          <p:cNvPr id="20" name="Text 17"/>
-          <p:cNvSpPr/>
-          <p:nvPr/>
-        </p:nvSpPr>
-        <p:spPr>
-          <a:xfrm>
-            <a:off x="566928" y="5961888"/>
-            <a:ext cx="5394960" cy="694944"/>
+          <p:cNvPr id="21" name="Text 18"/>
+          <p:cNvSpPr/>
+          <p:nvPr/>
+        </p:nvSpPr>
+        <p:spPr>
+          <a:xfrm>
+            <a:off x="566928" y="6126480"/>
+            <a:ext cx="5394960" cy="603504"/>
           </a:xfrm>
           <a:prstGeom prst="rect">
             <a:avLst/>
@@ -4593,7 +4632,7 @@
               <a:buNone/>
             </a:pPr>
             <a:r>
-              <a:rPr lang="en-US" sz="700" dirty="0">
+              <a:rPr lang="en-US" sz="650" dirty="0">
                 <a:solidFill>
                   <a:srgbClr val="5B7F8A"/>
                 </a:solidFill>
@@ -4603,7 +4642,7 @@
               </a:rPr>
               <a:t>This overview is a summary for discussion purposes only and is not an offer to sell or a solicitation of an offer to buy any security. Any offering is made only to accredited investors through definitive documents. Figures reflect launch pricing, third-party sold records, the Bondy Construction &amp; Design real-estate-owned schedule dated 21 March 2026, and the June 2026 proforma; all figures should be independently verified. Real estate investments involve risk, including loss of principal. Past performance of prior projects does not guarantee future results.</a:t>
             </a:r>
-            <a:endParaRPr lang="en-US" sz="700" dirty="0"/>
+            <a:endParaRPr lang="en-US" sz="650" dirty="0"/>
           </a:p>
         </p:txBody>
       </p:sp>
@@ -15797,7 +15836,7 @@
                 <a:ea typeface="Calibri" pitchFamily="34" charset="-122"/>
                 <a:cs typeface="Calibri" pitchFamily="34" charset="-120"/>
               </a:rPr>
-              <a:t>Kevin Simpson — AK Capital Investments, Investor Relations
+              <a:t>Kevin Simpson — Co-Developer &amp; Investor Relations, AK Capital Investments
 </a:t>
             </a:r>
             <a:pPr indent="0" marL="0">

</xml_diff>

<commit_message>
Reframe the deck as a debt investment rather than an offering
The cover read "SECURED NOTE OFFERING" directly above a disclaimer saying
the document is not an offer to sell securities. Naming the instrument is
both more accurate and more transparent than the sales framing.

- Cover now reads "Debt investment · Secured promissory note", and states
  up front that no equity is offered.
- "The Offer" section becomes "The debt investment"; its footnote now says
  plainly that the investor is lending, that interest is contractual rather
  than a share of profits, and that there is no upside beyond the rate.
- Replaces "offering package" with "diligence package" and names the actual
  documents an investor will review.

Co-Authored-By: Claude Opus 5 <noreply@anthropic.com>
Claude-Session: https://claude.ai/code/session_01CYAVPhQRHuvkVD16PJtbYL
</commit_message>
<xml_diff>
--- a/deck/3331-Trumbull-Investor-Deck-Aug-2026.pptx
+++ b/deck/3331-Trumbull-Investor-Deck-Aug-2026.pptx
@@ -2148,7 +2148,7 @@
                 <a:ea typeface="Calibri" pitchFamily="34" charset="-122"/>
                 <a:cs typeface="Calibri" pitchFamily="34" charset="-120"/>
               </a:rPr>
-              <a:t>PHASE 1 NOTE TRANCHE</a:t>
+              <a:t>PHASE 1 DEBT RAISE</a:t>
             </a:r>
             <a:endParaRPr lang="en-US" sz="780" dirty="0"/>
           </a:p>
@@ -2263,7 +2263,7 @@
         </p:nvSpPr>
         <p:spPr>
           <a:xfrm>
-            <a:off x="566928" y="4901184"/>
+            <a:off x="566928" y="4882896"/>
             <a:ext cx="4937760" cy="256032"/>
           </a:xfrm>
           <a:prstGeom prst="rect">
@@ -2288,7 +2288,7 @@
                 <a:ea typeface="Calibri" pitchFamily="34" charset="-122"/>
                 <a:cs typeface="Calibri" pitchFamily="34" charset="-120"/>
               </a:rPr>
-              <a:t>SECURED NOTE OFFERING   ·   AUGUST 2026</a:t>
+              <a:t>DEBT INVESTMENT  ·  SECURED PROMISSORY NOTE</a:t>
             </a:r>
             <a:endParaRPr lang="en-US" sz="1000" dirty="0"/>
           </a:p>
@@ -2302,7 +2302,46 @@
         </p:nvSpPr>
         <p:spPr>
           <a:xfrm>
-            <a:off x="566928" y="5230368"/>
+            <a:off x="566928" y="5157216"/>
+            <a:ext cx="4937760" cy="219456"/>
+          </a:xfrm>
+          <a:prstGeom prst="rect">
+            <a:avLst/>
+          </a:prstGeom>
+          <a:noFill/>
+          <a:ln/>
+        </p:spPr>
+        <p:txBody>
+          <a:bodyPr wrap="square" lIns="0" tIns="0" rIns="0" bIns="0" rtlCol="0" anchor="ctr"/>
+          <a:lstStyle/>
+          <a:p>
+            <a:pPr indent="0" marL="0">
+              <a:buNone/>
+            </a:pPr>
+            <a:r>
+              <a:rPr lang="en-US" sz="950" spc="140" kern="0" dirty="0">
+                <a:solidFill>
+                  <a:srgbClr val="9FC0C8"/>
+                </a:solidFill>
+                <a:latin typeface="Calibri" pitchFamily="34" charset="0"/>
+                <a:ea typeface="Calibri" pitchFamily="34" charset="-122"/>
+                <a:cs typeface="Calibri" pitchFamily="34" charset="-120"/>
+              </a:rPr>
+              <a:t>AUGUST 2026</a:t>
+            </a:r>
+            <a:endParaRPr lang="en-US" sz="950" dirty="0"/>
+          </a:p>
+        </p:txBody>
+      </p:sp>
+      <p:sp>
+        <p:nvSpPr>
+          <p:cNvPr id="19" name="Text 16"/>
+          <p:cNvSpPr/>
+          <p:nvPr/>
+        </p:nvSpPr>
+        <p:spPr>
+          <a:xfrm>
+            <a:off x="566928" y="5468112"/>
             <a:ext cx="4937760" cy="457200"/>
           </a:xfrm>
           <a:prstGeom prst="rect">
@@ -2330,7 +2369,7 @@
                 <a:ea typeface="Calibri" pitchFamily="34" charset="-122"/>
                 <a:cs typeface="Calibri" pitchFamily="34" charset="-120"/>
               </a:rPr>
-              <a:t>Confidential — prepared for the named recipient only. Not an offer to sell securities.</a:t>
+              <a:t>Debt only — no equity is offered. Confidential, prepared for the named recipient only. Not an offer to sell securities.</a:t>
             </a:r>
             <a:endParaRPr lang="en-US" sz="850" dirty="0"/>
           </a:p>
@@ -4341,7 +4380,7 @@
                 <a:ea typeface="Calibri" pitchFamily="34" charset="-122"/>
                 <a:cs typeface="Calibri" pitchFamily="34" charset="-120"/>
               </a:rPr>
-              <a:t>Note terms, comp book, CD set, and the June 2026 proforma.</a:t>
+              <a:t>Promissory note, personal guarantee, comp book, CD set, and the June 2026 proforma.</a:t>
             </a:r>
             <a:endParaRPr lang="en-US" sz="1050" dirty="0"/>
           </a:p>
@@ -6646,7 +6685,7 @@
                 <a:ea typeface="Calibri" pitchFamily="34" charset="-122"/>
                 <a:cs typeface="Calibri" pitchFamily="34" charset="-120"/>
               </a:rPr>
-              <a:t>THE OFFER</a:t>
+              <a:t>THE DEBT INVESTMENT</a:t>
             </a:r>
             <a:endParaRPr lang="en-US" sz="1050" dirty="0"/>
           </a:p>
@@ -8345,7 +8384,7 @@
                 <a:ea typeface="Calibri" pitchFamily="34" charset="-122"/>
                 <a:cs typeface="Calibri" pitchFamily="34" charset="-120"/>
               </a:rPr>
-              <a:t>Interest is a fixed contractual obligation of the borrower under the promissory note, not a projection. Seven $100,000 notes; accredited investors only.</a:t>
+              <a:t>This is a debt investment, not equity — you are lending to the borrower under a secured promissory note. Interest is a fixed contractual obligation, not a projection and not a share of profits; there is no upside beyond the stated rate. Seven $100,000 notes, accredited investors only.</a:t>
             </a:r>
             <a:endParaRPr lang="en-US" sz="850" dirty="0"/>
           </a:p>
@@ -11438,7 +11477,7 @@
                 <a:ea typeface="Calibri" pitchFamily="34" charset="-122"/>
                 <a:cs typeface="Calibri" pitchFamily="34" charset="-120"/>
               </a:rPr>
-              <a:t>Sources: Realcomp IDX sold records (June–July 2026 pulls), ALTA seller settlement statements, and builder price lists, per Bondy Construction &amp; Design. Full comp book with unit-level closings is in the offering package. All figures should be independently verified.</a:t>
+              <a:t>Sources: Realcomp IDX sold records (June–July 2026 pulls), ALTA seller settlement statements, and builder price lists, per Bondy Construction &amp; Design. Full comp book with unit-level closings is in the diligence package. All figures should be independently verified.</a:t>
             </a:r>
             <a:endParaRPr lang="en-US" sz="850" dirty="0"/>
           </a:p>

</xml_diff>

<commit_message>
Rebuild the cover so the rendering actually reads
The aerial was cropped into a tall half-slide window. Its source is
landscape, so filling that window chopped the development down to a corner
of one building, and the semi-transparent overlay strip left a visible
seam down the middle of the slide.

The rendering is now full-bleed with the type in the lower left. The dark
field behind the type is a real gradient composited into the image itself,
anchored bottom-left and falling away up and to the right, which removes
the seam and lets the whole block show.

Co-Authored-By: Claude Opus 5 <noreply@anthropic.com>
Claude-Session: https://claude.ai/code/session_01CYAVPhQRHuvkVD16PJtbYL
</commit_message>
<xml_diff>
--- a/deck/3331-Trumbull-Investor-Deck-Aug-2026.pptx
+++ b/deck/3331-Trumbull-Investor-Deck-Aug-2026.pptx
@@ -1767,7 +1767,7 @@
       </p:grpSpPr>
       <p:pic>
         <p:nvPicPr>
-          <p:cNvPr id="2" name="Image 0" descr="/home/user/3331-trumbull/deck/img/rendering-aerial.jpg">    </p:cNvPr>
+          <p:cNvPr id="2" name="Image 0" descr="/home/user/3331-trumbull/deck/img/hero-aerial.jpg">    </p:cNvPr>
           <p:cNvPicPr>
             <a:picLocks noChangeAspect="1"/>
           </p:cNvPicPr>
@@ -1775,13 +1775,14 @@
         </p:nvPicPr>
         <p:blipFill>
           <a:blip r:embed="rId1"/>
-          <a:srcRect l="0" r="0" t="0" b="0"/>
-          <a:stretch/>
+          <a:stretch>
+            <a:fillRect/>
+          </a:stretch>
         </p:blipFill>
         <p:spPr>
           <a:xfrm>
-            <a:off x="6035040" y="0"/>
-            <a:ext cx="6126480" cy="6858000"/>
+            <a:off x="0" y="0"/>
+            <a:ext cx="12161520" cy="6858000"/>
           </a:xfrm>
           <a:prstGeom prst="rect">
             <a:avLst/>
@@ -1796,72 +1797,8 @@
         </p:nvSpPr>
         <p:spPr>
           <a:xfrm>
-            <a:off x="6035040" y="0"/>
-            <a:ext cx="6126480" cy="6858000"/>
-          </a:xfrm>
-          <a:prstGeom prst="rect">
-            <a:avLst/>
-          </a:prstGeom>
-          <a:solidFill>
-            <a:srgbClr val="12303C">
-              <a:alpha val="58000"/>
-            </a:srgbClr>
-          </a:solidFill>
-          <a:ln/>
-        </p:spPr>
-      </p:sp>
-      <p:sp>
-        <p:nvSpPr>
-          <p:cNvPr id="4" name="Shape 1"/>
-          <p:cNvSpPr/>
-          <p:nvPr/>
-        </p:nvSpPr>
-        <p:spPr>
-          <a:xfrm>
-            <a:off x="5486400" y="0"/>
-            <a:ext cx="1097280" cy="6858000"/>
-          </a:xfrm>
-          <a:prstGeom prst="rect">
-            <a:avLst/>
-          </a:prstGeom>
-          <a:solidFill>
-            <a:srgbClr val="12303C">
-              <a:alpha val="70000"/>
-            </a:srgbClr>
-          </a:solidFill>
-          <a:ln/>
-        </p:spPr>
-      </p:sp>
-      <p:sp>
-        <p:nvSpPr>
-          <p:cNvPr id="5" name="Shape 2"/>
-          <p:cNvSpPr/>
-          <p:nvPr/>
-        </p:nvSpPr>
-        <p:spPr>
-          <a:xfrm>
-            <a:off x="0" y="0"/>
-            <a:ext cx="5852160" cy="6858000"/>
-          </a:xfrm>
-          <a:prstGeom prst="rect">
-            <a:avLst/>
-          </a:prstGeom>
-          <a:solidFill>
-            <a:srgbClr val="12303C"/>
-          </a:solidFill>
-          <a:ln/>
-        </p:spPr>
-      </p:sp>
-      <p:sp>
-        <p:nvSpPr>
-          <p:cNvPr id="6" name="Shape 3"/>
-          <p:cNvSpPr/>
-          <p:nvPr/>
-        </p:nvSpPr>
-        <p:spPr>
-          <a:xfrm>
-            <a:off x="566928" y="987552"/>
-            <a:ext cx="118872" cy="118872"/>
+            <a:off x="566928" y="3127248"/>
+            <a:ext cx="100584" cy="100584"/>
           </a:xfrm>
           <a:prstGeom prst="rect">
             <a:avLst/>
@@ -1874,14 +1811,14 @@
       </p:sp>
       <p:sp>
         <p:nvSpPr>
-          <p:cNvPr id="7" name="Text 4"/>
-          <p:cNvSpPr/>
-          <p:nvPr/>
-        </p:nvSpPr>
-        <p:spPr>
-          <a:xfrm>
-            <a:off x="804672" y="914400"/>
-            <a:ext cx="4937760" cy="274320"/>
+          <p:cNvPr id="4" name="Text 1"/>
+          <p:cNvSpPr/>
+          <p:nvPr/>
+        </p:nvSpPr>
+        <p:spPr>
+          <a:xfrm>
+            <a:off x="786384" y="3063240"/>
+            <a:ext cx="5120640" cy="237744"/>
           </a:xfrm>
           <a:prstGeom prst="rect">
             <a:avLst/>
@@ -1913,30 +1850,30 @@
       </p:sp>
       <p:sp>
         <p:nvSpPr>
-          <p:cNvPr id="8" name="Text 5"/>
-          <p:cNvSpPr/>
-          <p:nvPr/>
-        </p:nvSpPr>
-        <p:spPr>
-          <a:xfrm>
-            <a:off x="566928" y="1371600"/>
-            <a:ext cx="5120640" cy="868680"/>
-          </a:xfrm>
-          <a:prstGeom prst="rect">
-            <a:avLst/>
-          </a:prstGeom>
-          <a:noFill/>
-          <a:ln/>
-        </p:spPr>
-        <p:txBody>
-          <a:bodyPr wrap="square" lIns="0" tIns="0" rIns="0" bIns="0" rtlCol="0" anchor="ctr"/>
-          <a:lstStyle/>
-          <a:p>
-            <a:pPr indent="0" marL="0">
-              <a:buNone/>
-            </a:pPr>
-            <a:r>
-              <a:rPr lang="en-US" sz="4200" b="1" dirty="0">
+          <p:cNvPr id="5" name="Text 2"/>
+          <p:cNvSpPr/>
+          <p:nvPr/>
+        </p:nvSpPr>
+        <p:spPr>
+          <a:xfrm>
+            <a:off x="566928" y="3346704"/>
+            <a:ext cx="5303520" cy="731520"/>
+          </a:xfrm>
+          <a:prstGeom prst="rect">
+            <a:avLst/>
+          </a:prstGeom>
+          <a:noFill/>
+          <a:ln/>
+        </p:spPr>
+        <p:txBody>
+          <a:bodyPr wrap="square" lIns="0" tIns="0" rIns="0" bIns="0" rtlCol="0" anchor="ctr"/>
+          <a:lstStyle/>
+          <a:p>
+            <a:pPr indent="0" marL="0">
+              <a:buNone/>
+            </a:pPr>
+            <a:r>
+              <a:rPr lang="en-US" sz="4000" b="1" dirty="0">
                 <a:solidFill>
                   <a:srgbClr val="FFFFFF"/>
                 </a:solidFill>
@@ -1946,20 +1883,20 @@
               </a:rPr>
               <a:t>3331 Trumbull</a:t>
             </a:r>
-            <a:endParaRPr lang="en-US" sz="4200" dirty="0"/>
-          </a:p>
-        </p:txBody>
-      </p:sp>
-      <p:sp>
-        <p:nvSpPr>
-          <p:cNvPr id="9" name="Text 6"/>
-          <p:cNvSpPr/>
-          <p:nvPr/>
-        </p:nvSpPr>
-        <p:spPr>
-          <a:xfrm>
-            <a:off x="566928" y="2286000"/>
-            <a:ext cx="4846320" cy="1005840"/>
+            <a:endParaRPr lang="en-US" sz="4000" dirty="0"/>
+          </a:p>
+        </p:txBody>
+      </p:sp>
+      <p:sp>
+        <p:nvSpPr>
+          <p:cNvPr id="6" name="Text 3"/>
+          <p:cNvSpPr/>
+          <p:nvPr/>
+        </p:nvSpPr>
+        <p:spPr>
+          <a:xfrm>
+            <a:off x="566928" y="4114800"/>
+            <a:ext cx="5120640" cy="603504"/>
           </a:xfrm>
           <a:prstGeom prst="rect">
             <a:avLst/>
@@ -1973,14 +1910,14 @@
           <a:p>
             <a:pPr indent="0" marL="0">
               <a:lnSpc>
-                <a:spcPts val="2100"/>
+                <a:spcPts val="2000"/>
               </a:lnSpc>
               <a:buNone/>
             </a:pPr>
             <a:r>
-              <a:rPr lang="en-US" sz="1400" dirty="0">
-                <a:solidFill>
-                  <a:srgbClr val="C6DADE"/>
+              <a:rPr lang="en-US" sz="1350" dirty="0">
+                <a:solidFill>
+                  <a:srgbClr val="D2E3E7"/>
                 </a:solidFill>
                 <a:latin typeface="Calibri" pitchFamily="34" charset="0"/>
                 <a:ea typeface="Calibri" pitchFamily="34" charset="-122"/>
@@ -1988,36 +1925,36 @@
               </a:rPr>
               <a:t>Twenty-five for-sale townhomes on a full city block in North Corktown, Detroit — built in two phases.</a:t>
             </a:r>
-            <a:endParaRPr lang="en-US" sz="1400" dirty="0"/>
-          </a:p>
-        </p:txBody>
-      </p:sp>
-      <p:sp>
-        <p:nvSpPr>
-          <p:cNvPr id="10" name="Text 7"/>
-          <p:cNvSpPr/>
-          <p:nvPr/>
-        </p:nvSpPr>
-        <p:spPr>
-          <a:xfrm>
-            <a:off x="566928" y="3566160"/>
-            <a:ext cx="1554480" cy="384048"/>
-          </a:xfrm>
-          <a:prstGeom prst="rect">
-            <a:avLst/>
-          </a:prstGeom>
-          <a:noFill/>
-          <a:ln/>
-        </p:spPr>
-        <p:txBody>
-          <a:bodyPr wrap="square" lIns="0" tIns="0" rIns="0" bIns="0" rtlCol="0" anchor="ctr"/>
-          <a:lstStyle/>
-          <a:p>
-            <a:pPr indent="0" marL="0">
-              <a:buNone/>
-            </a:pPr>
-            <a:r>
-              <a:rPr lang="en-US" sz="2100" b="1" dirty="0">
+            <a:endParaRPr lang="en-US" sz="1350" dirty="0"/>
+          </a:p>
+        </p:txBody>
+      </p:sp>
+      <p:sp>
+        <p:nvSpPr>
+          <p:cNvPr id="7" name="Text 4"/>
+          <p:cNvSpPr/>
+          <p:nvPr/>
+        </p:nvSpPr>
+        <p:spPr>
+          <a:xfrm>
+            <a:off x="566928" y="4846320"/>
+            <a:ext cx="1554480" cy="365760"/>
+          </a:xfrm>
+          <a:prstGeom prst="rect">
+            <a:avLst/>
+          </a:prstGeom>
+          <a:noFill/>
+          <a:ln/>
+        </p:spPr>
+        <p:txBody>
+          <a:bodyPr wrap="square" lIns="0" tIns="0" rIns="0" bIns="0" rtlCol="0" anchor="ctr"/>
+          <a:lstStyle/>
+          <a:p>
+            <a:pPr indent="0" marL="0">
+              <a:buNone/>
+            </a:pPr>
+            <a:r>
+              <a:rPr lang="en-US" sz="2000" b="1" dirty="0">
                 <a:solidFill>
                   <a:srgbClr val="FFFFFF"/>
                 </a:solidFill>
@@ -2027,20 +1964,20 @@
               </a:rPr>
               <a:t>13 + 12</a:t>
             </a:r>
-            <a:endParaRPr lang="en-US" sz="2100" dirty="0"/>
-          </a:p>
-        </p:txBody>
-      </p:sp>
-      <p:sp>
-        <p:nvSpPr>
-          <p:cNvPr id="11" name="Text 8"/>
-          <p:cNvSpPr/>
-          <p:nvPr/>
-        </p:nvSpPr>
-        <p:spPr>
-          <a:xfrm>
-            <a:off x="566928" y="3959352"/>
-            <a:ext cx="1554480" cy="457200"/>
+            <a:endParaRPr lang="en-US" sz="2000" dirty="0"/>
+          </a:p>
+        </p:txBody>
+      </p:sp>
+      <p:sp>
+        <p:nvSpPr>
+          <p:cNvPr id="8" name="Text 5"/>
+          <p:cNvSpPr/>
+          <p:nvPr/>
+        </p:nvSpPr>
+        <p:spPr>
+          <a:xfrm>
+            <a:off x="566928" y="5212080"/>
+            <a:ext cx="1554480" cy="274320"/>
           </a:xfrm>
           <a:prstGeom prst="rect">
             <a:avLst/>
@@ -2059,7 +1996,7 @@
               <a:buNone/>
             </a:pPr>
             <a:r>
-              <a:rPr lang="en-US" sz="780" spc="80" kern="0" dirty="0">
+              <a:rPr lang="en-US" sz="760" spc="70" kern="0" dirty="0">
                 <a:solidFill>
                   <a:srgbClr val="9FC0C8"/>
                 </a:solidFill>
@@ -2069,36 +2006,36 @@
               </a:rPr>
               <a:t>UNITS, PHASE 1 / PHASE 2</a:t>
             </a:r>
-            <a:endParaRPr lang="en-US" sz="780" dirty="0"/>
-          </a:p>
-        </p:txBody>
-      </p:sp>
-      <p:sp>
-        <p:nvSpPr>
-          <p:cNvPr id="12" name="Text 9"/>
-          <p:cNvSpPr/>
-          <p:nvPr/>
-        </p:nvSpPr>
-        <p:spPr>
-          <a:xfrm>
-            <a:off x="2194560" y="3566160"/>
-            <a:ext cx="1554480" cy="384048"/>
-          </a:xfrm>
-          <a:prstGeom prst="rect">
-            <a:avLst/>
-          </a:prstGeom>
-          <a:noFill/>
-          <a:ln/>
-        </p:spPr>
-        <p:txBody>
-          <a:bodyPr wrap="square" lIns="0" tIns="0" rIns="0" bIns="0" rtlCol="0" anchor="ctr"/>
-          <a:lstStyle/>
-          <a:p>
-            <a:pPr indent="0" marL="0">
-              <a:buNone/>
-            </a:pPr>
-            <a:r>
-              <a:rPr lang="en-US" sz="2100" b="1" dirty="0">
+            <a:endParaRPr lang="en-US" sz="760" dirty="0"/>
+          </a:p>
+        </p:txBody>
+      </p:sp>
+      <p:sp>
+        <p:nvSpPr>
+          <p:cNvPr id="9" name="Text 6"/>
+          <p:cNvSpPr/>
+          <p:nvPr/>
+        </p:nvSpPr>
+        <p:spPr>
+          <a:xfrm>
+            <a:off x="2194560" y="4846320"/>
+            <a:ext cx="1554480" cy="365760"/>
+          </a:xfrm>
+          <a:prstGeom prst="rect">
+            <a:avLst/>
+          </a:prstGeom>
+          <a:noFill/>
+          <a:ln/>
+        </p:spPr>
+        <p:txBody>
+          <a:bodyPr wrap="square" lIns="0" tIns="0" rIns="0" bIns="0" rtlCol="0" anchor="ctr"/>
+          <a:lstStyle/>
+          <a:p>
+            <a:pPr indent="0" marL="0">
+              <a:buNone/>
+            </a:pPr>
+            <a:r>
+              <a:rPr lang="en-US" sz="2000" b="1" dirty="0">
                 <a:solidFill>
                   <a:srgbClr val="FFFFFF"/>
                 </a:solidFill>
@@ -2108,20 +2045,20 @@
               </a:rPr>
               <a:t>$700K</a:t>
             </a:r>
-            <a:endParaRPr lang="en-US" sz="2100" dirty="0"/>
-          </a:p>
-        </p:txBody>
-      </p:sp>
-      <p:sp>
-        <p:nvSpPr>
-          <p:cNvPr id="13" name="Text 10"/>
-          <p:cNvSpPr/>
-          <p:nvPr/>
-        </p:nvSpPr>
-        <p:spPr>
-          <a:xfrm>
-            <a:off x="2194560" y="3959352"/>
-            <a:ext cx="1554480" cy="457200"/>
+            <a:endParaRPr lang="en-US" sz="2000" dirty="0"/>
+          </a:p>
+        </p:txBody>
+      </p:sp>
+      <p:sp>
+        <p:nvSpPr>
+          <p:cNvPr id="10" name="Text 7"/>
+          <p:cNvSpPr/>
+          <p:nvPr/>
+        </p:nvSpPr>
+        <p:spPr>
+          <a:xfrm>
+            <a:off x="2194560" y="5212080"/>
+            <a:ext cx="1554480" cy="274320"/>
           </a:xfrm>
           <a:prstGeom prst="rect">
             <a:avLst/>
@@ -2140,7 +2077,7 @@
               <a:buNone/>
             </a:pPr>
             <a:r>
-              <a:rPr lang="en-US" sz="780" spc="80" kern="0" dirty="0">
+              <a:rPr lang="en-US" sz="760" spc="70" kern="0" dirty="0">
                 <a:solidFill>
                   <a:srgbClr val="9FC0C8"/>
                 </a:solidFill>
@@ -2150,36 +2087,36 @@
               </a:rPr>
               <a:t>PHASE 1 DEBT RAISE</a:t>
             </a:r>
-            <a:endParaRPr lang="en-US" sz="780" dirty="0"/>
-          </a:p>
-        </p:txBody>
-      </p:sp>
-      <p:sp>
-        <p:nvSpPr>
-          <p:cNvPr id="14" name="Text 11"/>
-          <p:cNvSpPr/>
-          <p:nvPr/>
-        </p:nvSpPr>
-        <p:spPr>
-          <a:xfrm>
-            <a:off x="3822192" y="3566160"/>
-            <a:ext cx="1554480" cy="384048"/>
-          </a:xfrm>
-          <a:prstGeom prst="rect">
-            <a:avLst/>
-          </a:prstGeom>
-          <a:noFill/>
-          <a:ln/>
-        </p:spPr>
-        <p:txBody>
-          <a:bodyPr wrap="square" lIns="0" tIns="0" rIns="0" bIns="0" rtlCol="0" anchor="ctr"/>
-          <a:lstStyle/>
-          <a:p>
-            <a:pPr indent="0" marL="0">
-              <a:buNone/>
-            </a:pPr>
-            <a:r>
-              <a:rPr lang="en-US" sz="2100" b="1" dirty="0">
+            <a:endParaRPr lang="en-US" sz="760" dirty="0"/>
+          </a:p>
+        </p:txBody>
+      </p:sp>
+      <p:sp>
+        <p:nvSpPr>
+          <p:cNvPr id="11" name="Text 8"/>
+          <p:cNvSpPr/>
+          <p:nvPr/>
+        </p:nvSpPr>
+        <p:spPr>
+          <a:xfrm>
+            <a:off x="3822192" y="4846320"/>
+            <a:ext cx="1554480" cy="365760"/>
+          </a:xfrm>
+          <a:prstGeom prst="rect">
+            <a:avLst/>
+          </a:prstGeom>
+          <a:noFill/>
+          <a:ln/>
+        </p:spPr>
+        <p:txBody>
+          <a:bodyPr wrap="square" lIns="0" tIns="0" rIns="0" bIns="0" rtlCol="0" anchor="ctr"/>
+          <a:lstStyle/>
+          <a:p>
+            <a:pPr indent="0" marL="0">
+              <a:buNone/>
+            </a:pPr>
+            <a:r>
+              <a:rPr lang="en-US" sz="2000" b="1" dirty="0">
                 <a:solidFill>
                   <a:srgbClr val="FFFFFF"/>
                 </a:solidFill>
@@ -2189,20 +2126,20 @@
               </a:rPr>
               <a:t>20%</a:t>
             </a:r>
-            <a:endParaRPr lang="en-US" sz="2100" dirty="0"/>
-          </a:p>
-        </p:txBody>
-      </p:sp>
-      <p:sp>
-        <p:nvSpPr>
-          <p:cNvPr id="15" name="Text 12"/>
-          <p:cNvSpPr/>
-          <p:nvPr/>
-        </p:nvSpPr>
-        <p:spPr>
-          <a:xfrm>
-            <a:off x="3822192" y="3959352"/>
-            <a:ext cx="1554480" cy="457200"/>
+            <a:endParaRPr lang="en-US" sz="2000" dirty="0"/>
+          </a:p>
+        </p:txBody>
+      </p:sp>
+      <p:sp>
+        <p:nvSpPr>
+          <p:cNvPr id="12" name="Text 9"/>
+          <p:cNvSpPr/>
+          <p:nvPr/>
+        </p:nvSpPr>
+        <p:spPr>
+          <a:xfrm>
+            <a:off x="3822192" y="5212080"/>
+            <a:ext cx="1554480" cy="274320"/>
           </a:xfrm>
           <a:prstGeom prst="rect">
             <a:avLst/>
@@ -2221,7 +2158,7 @@
               <a:buNone/>
             </a:pPr>
             <a:r>
-              <a:rPr lang="en-US" sz="780" spc="80" kern="0" dirty="0">
+              <a:rPr lang="en-US" sz="760" spc="70" kern="0" dirty="0">
                 <a:solidFill>
                   <a:srgbClr val="9FC0C8"/>
                 </a:solidFill>
@@ -2231,56 +2168,56 @@
               </a:rPr>
               <a:t>FIXED, PAID QUARTERLY</a:t>
             </a:r>
-            <a:endParaRPr lang="en-US" sz="780" dirty="0"/>
-          </a:p>
-        </p:txBody>
-      </p:sp>
-      <p:sp>
-        <p:nvSpPr>
-          <p:cNvPr id="16" name="Shape 13"/>
-          <p:cNvSpPr/>
-          <p:nvPr/>
-        </p:nvSpPr>
-        <p:spPr>
-          <a:xfrm>
-            <a:off x="566928" y="4736592"/>
-            <a:ext cx="4937760" cy="10973"/>
+            <a:endParaRPr lang="en-US" sz="760" dirty="0"/>
+          </a:p>
+        </p:txBody>
+      </p:sp>
+      <p:sp>
+        <p:nvSpPr>
+          <p:cNvPr id="13" name="Shape 10"/>
+          <p:cNvSpPr/>
+          <p:nvPr/>
+        </p:nvSpPr>
+        <p:spPr>
+          <a:xfrm>
+            <a:off x="566928" y="5669280"/>
+            <a:ext cx="5120640" cy="10973"/>
           </a:xfrm>
           <a:prstGeom prst="rect">
             <a:avLst/>
           </a:prstGeom>
           <a:solidFill>
-            <a:srgbClr val="2C5566"/>
+            <a:srgbClr val="3C6272"/>
           </a:solidFill>
           <a:ln/>
         </p:spPr>
       </p:sp>
       <p:sp>
         <p:nvSpPr>
-          <p:cNvPr id="17" name="Text 14"/>
-          <p:cNvSpPr/>
-          <p:nvPr/>
-        </p:nvSpPr>
-        <p:spPr>
-          <a:xfrm>
-            <a:off x="566928" y="4882896"/>
-            <a:ext cx="4937760" cy="256032"/>
-          </a:xfrm>
-          <a:prstGeom prst="rect">
-            <a:avLst/>
-          </a:prstGeom>
-          <a:noFill/>
-          <a:ln/>
-        </p:spPr>
-        <p:txBody>
-          <a:bodyPr wrap="square" lIns="0" tIns="0" rIns="0" bIns="0" rtlCol="0" anchor="ctr"/>
-          <a:lstStyle/>
-          <a:p>
-            <a:pPr indent="0" marL="0">
-              <a:buNone/>
-            </a:pPr>
-            <a:r>
-              <a:rPr lang="en-US" sz="1000" b="1" spc="140" kern="0" dirty="0">
+          <p:cNvPr id="14" name="Text 11"/>
+          <p:cNvSpPr/>
+          <p:nvPr/>
+        </p:nvSpPr>
+        <p:spPr>
+          <a:xfrm>
+            <a:off x="566928" y="5797296"/>
+            <a:ext cx="5303520" cy="237744"/>
+          </a:xfrm>
+          <a:prstGeom prst="rect">
+            <a:avLst/>
+          </a:prstGeom>
+          <a:noFill/>
+          <a:ln/>
+        </p:spPr>
+        <p:txBody>
+          <a:bodyPr wrap="square" lIns="0" tIns="0" rIns="0" bIns="0" rtlCol="0" anchor="ctr"/>
+          <a:lstStyle/>
+          <a:p>
+            <a:pPr indent="0" marL="0">
+              <a:buNone/>
+            </a:pPr>
+            <a:r>
+              <a:rPr lang="en-US" sz="900" b="1" spc="110" kern="0" dirty="0">
                 <a:solidFill>
                   <a:srgbClr val="E3C581"/>
                 </a:solidFill>
@@ -2288,61 +2225,22 @@
                 <a:ea typeface="Calibri" pitchFamily="34" charset="-122"/>
                 <a:cs typeface="Calibri" pitchFamily="34" charset="-120"/>
               </a:rPr>
-              <a:t>DEBT INVESTMENT  ·  SECURED PROMISSORY NOTE</a:t>
-            </a:r>
-            <a:endParaRPr lang="en-US" sz="1000" dirty="0"/>
-          </a:p>
-        </p:txBody>
-      </p:sp>
-      <p:sp>
-        <p:nvSpPr>
-          <p:cNvPr id="18" name="Text 15"/>
-          <p:cNvSpPr/>
-          <p:nvPr/>
-        </p:nvSpPr>
-        <p:spPr>
-          <a:xfrm>
-            <a:off x="566928" y="5157216"/>
-            <a:ext cx="4937760" cy="219456"/>
-          </a:xfrm>
-          <a:prstGeom prst="rect">
-            <a:avLst/>
-          </a:prstGeom>
-          <a:noFill/>
-          <a:ln/>
-        </p:spPr>
-        <p:txBody>
-          <a:bodyPr wrap="square" lIns="0" tIns="0" rIns="0" bIns="0" rtlCol="0" anchor="ctr"/>
-          <a:lstStyle/>
-          <a:p>
-            <a:pPr indent="0" marL="0">
-              <a:buNone/>
-            </a:pPr>
-            <a:r>
-              <a:rPr lang="en-US" sz="950" spc="140" kern="0" dirty="0">
-                <a:solidFill>
-                  <a:srgbClr val="9FC0C8"/>
-                </a:solidFill>
-                <a:latin typeface="Calibri" pitchFamily="34" charset="0"/>
-                <a:ea typeface="Calibri" pitchFamily="34" charset="-122"/>
-                <a:cs typeface="Calibri" pitchFamily="34" charset="-120"/>
-              </a:rPr>
-              <a:t>AUGUST 2026</a:t>
-            </a:r>
-            <a:endParaRPr lang="en-US" sz="950" dirty="0"/>
-          </a:p>
-        </p:txBody>
-      </p:sp>
-      <p:sp>
-        <p:nvSpPr>
-          <p:cNvPr id="19" name="Text 16"/>
-          <p:cNvSpPr/>
-          <p:nvPr/>
-        </p:nvSpPr>
-        <p:spPr>
-          <a:xfrm>
-            <a:off x="566928" y="5468112"/>
-            <a:ext cx="4937760" cy="457200"/>
+              <a:t>DEBT INVESTMENT  ·  SECURED PROMISSORY NOTE  ·  AUGUST 2026</a:t>
+            </a:r>
+            <a:endParaRPr lang="en-US" sz="900" dirty="0"/>
+          </a:p>
+        </p:txBody>
+      </p:sp>
+      <p:sp>
+        <p:nvSpPr>
+          <p:cNvPr id="15" name="Text 12"/>
+          <p:cNvSpPr/>
+          <p:nvPr/>
+        </p:nvSpPr>
+        <p:spPr>
+          <a:xfrm>
+            <a:off x="566928" y="6089904"/>
+            <a:ext cx="5120640" cy="402336"/>
           </a:xfrm>
           <a:prstGeom prst="rect">
             <a:avLst/>
@@ -2356,14 +2254,14 @@
           <a:p>
             <a:pPr indent="0" marL="0">
               <a:lnSpc>
-                <a:spcPts val="1100"/>
+                <a:spcPts val="1000"/>
               </a:lnSpc>
               <a:buNone/>
             </a:pPr>
             <a:r>
-              <a:rPr lang="en-US" sz="850" dirty="0">
-                <a:solidFill>
-                  <a:srgbClr val="5B7F8A"/>
+              <a:rPr lang="en-US" sz="800" dirty="0">
+                <a:solidFill>
+                  <a:srgbClr val="8FAAB4"/>
                 </a:solidFill>
                 <a:latin typeface="Calibri" pitchFamily="34" charset="0"/>
                 <a:ea typeface="Calibri" pitchFamily="34" charset="-122"/>
@@ -2371,7 +2269,7 @@
               </a:rPr>
               <a:t>Debt only — no equity is offered. Confidential, prepared for the named recipient only. Not an offer to sell securities.</a:t>
             </a:r>
-            <a:endParaRPr lang="en-US" sz="850" dirty="0"/>
+            <a:endParaRPr lang="en-US" sz="800" dirty="0"/>
           </a:p>
         </p:txBody>
       </p:sp>

</xml_diff>

<commit_message>
Correct the blended price per square foot to $285
$288 is total revenue divided by saleable area, so it folds in the
$125,000 upgrade allowance. Labeling it a launch price was wrong, and it
is the figure compared against closed comps on the market evidence slide.

Blended launch pricing is $10,633,862 over 37,311 sf = $285/sf, which is
what the $282-292 launch row in the comp table describes and what belongs
next to the $320 Sycamore Park blended closing. Applied on both the market
evidence and financials slides.

Also relabels the $10.76M headline stat as total projected revenue rather
than gross revenue, matching the proforma line it comes from.

Co-Authored-By: Claude Opus 5 <noreply@anthropic.com>
Claude-Session: https://claude.ai/code/session_01CYAVPhQRHuvkVD16PJtbYL
</commit_message>
<xml_diff>
--- a/deck/3331-Trumbull-Investor-Deck-Aug-2026.pptx
+++ b/deck/3331-Trumbull-Investor-Deck-Aug-2026.pptx
@@ -5064,7 +5064,7 @@
                 <a:ea typeface="Calibri" pitchFamily="34" charset="-122"/>
                 <a:cs typeface="Calibri" pitchFamily="34" charset="-120"/>
               </a:rPr>
-              <a:t>PROJECTED</a:t>
+              <a:t>TOTAL PROJECTED</a:t>
             </a:r>
             <a:endParaRPr lang="en-US" sz="850" dirty="0"/>
           </a:p>
@@ -5084,7 +5084,7 @@
                 <a:ea typeface="Calibri" pitchFamily="34" charset="-122"/>
                 <a:cs typeface="Calibri" pitchFamily="34" charset="-120"/>
               </a:rPr>
-              <a:t>GROSS REVENUE</a:t>
+              <a:t>REVENUE</a:t>
             </a:r>
             <a:endParaRPr lang="en-US" sz="850" dirty="0"/>
           </a:p>
@@ -11493,7 +11493,7 @@
                 <a:ea typeface="Cambria" pitchFamily="34" charset="-122"/>
                 <a:cs typeface="Cambria" pitchFamily="34" charset="-120"/>
               </a:rPr>
-              <a:t>$288</a:t>
+              <a:t>$285</a:t>
             </a:r>
             <a:endParaRPr lang="en-US" sz="3000" dirty="0"/>
           </a:p>
@@ -12861,7 +12861,7 @@
                 <a:ea typeface="Cambria" pitchFamily="34" charset="-122"/>
                 <a:cs typeface="Cambria" pitchFamily="34" charset="-120"/>
               </a:rPr>
-              <a:t>$288</a:t>
+              <a:t>$285</a:t>
             </a:r>
             <a:endParaRPr lang="en-US" sz="2500" dirty="0"/>
           </a:p>
@@ -12903,7 +12903,7 @@
                 <a:ea typeface="Calibri" pitchFamily="34" charset="-122"/>
                 <a:cs typeface="Calibri" pitchFamily="34" charset="-120"/>
               </a:rPr>
-              <a:t>BLENDED PRICE</a:t>
+              <a:t>BLENDED LAUNCH</a:t>
             </a:r>
             <a:endParaRPr lang="en-US" sz="850" dirty="0"/>
           </a:p>
@@ -12923,7 +12923,7 @@
                 <a:ea typeface="Calibri" pitchFamily="34" charset="-122"/>
                 <a:cs typeface="Calibri" pitchFamily="34" charset="-120"/>
               </a:rPr>
-              <a:t>PER SQUARE FOOT</a:t>
+              <a:t>PRICE PER SF</a:t>
             </a:r>
             <a:endParaRPr lang="en-US" sz="850" dirty="0"/>
           </a:p>

</xml_diff>